<commit_message>
Localize and simplify system architecture diagram
</commit_message>
<xml_diff>
--- a/docs/protopedia_assets/souzoku_shield_protopedia_visuals.pptx
+++ b/docs/protopedia_assets/souzoku_shield_protopedia_visuals.pptx
@@ -2,16 +2,16 @@
 <file path=ppt/presentation.xml><?xml version="1.0" encoding="utf-8"?>
 <p:presentation xmlns:p="http://schemas.openxmlformats.org/presentationml/2006/main">
   <p:sldMasterIdLst>
-    <p:sldMasterId xmlns:r="http://schemas.openxmlformats.org/officeDocument/2006/relationships" id="2147483648" r:id="R41df96a85fa14cda"/>
+    <p:sldMasterId xmlns:r="http://schemas.openxmlformats.org/officeDocument/2006/relationships" id="2147483648" r:id="R6fcd5ddbdb7e4cb0"/>
   </p:sldMasterIdLst>
   <p:notesMasterIdLst>
-    <p:notesMasterId xmlns:r="http://schemas.openxmlformats.org/officeDocument/2006/relationships" r:id="Ra4e415d5ca8b49fb"/>
+    <p:notesMasterId xmlns:r="http://schemas.openxmlformats.org/officeDocument/2006/relationships" r:id="R6a5720fd64ee424c"/>
   </p:notesMasterIdLst>
   <p:sldIdLst>
-    <p:sldId xmlns:r="http://schemas.openxmlformats.org/officeDocument/2006/relationships" id="256" r:id="Rc4b104fb7e5d423d"/>
-    <p:sldId xmlns:r="http://schemas.openxmlformats.org/officeDocument/2006/relationships" id="257" r:id="R52e3f3a853e74c59"/>
-    <p:sldId xmlns:r="http://schemas.openxmlformats.org/officeDocument/2006/relationships" id="258" r:id="R4de5f2d4ba384fab"/>
-    <p:sldId xmlns:r="http://schemas.openxmlformats.org/officeDocument/2006/relationships" id="259" r:id="R590bdfa2045649fa"/>
+    <p:sldId xmlns:r="http://schemas.openxmlformats.org/officeDocument/2006/relationships" id="256" r:id="R3c8b02574e044b9e"/>
+    <p:sldId xmlns:r="http://schemas.openxmlformats.org/officeDocument/2006/relationships" id="257" r:id="R52a0e328af5145ff"/>
+    <p:sldId xmlns:r="http://schemas.openxmlformats.org/officeDocument/2006/relationships" id="258" r:id="R5f9b6874e26b48a9"/>
+    <p:sldId xmlns:r="http://schemas.openxmlformats.org/officeDocument/2006/relationships" id="259" r:id="R2a89a9c9c7044169"/>
   </p:sldIdLst>
   <p:sldSz cx="9753600" cy="5486400"/>
   <p:notesSz cx="6858000" cy="9144000"/>
@@ -802,7 +802,7 @@
   </p:cSld>
   <p:clrMap bg1="lt1" tx1="dk1" bg2="lt2" tx2="dk2" accent1="accent1" accent2="accent2" accent3="accent3" accent4="accent4" accent5="accent5" accent6="accent6" hlink="hlink" folHlink="folHlink"/>
   <p:sldLayoutIdLst>
-    <p:sldLayoutId xmlns:r="http://schemas.openxmlformats.org/officeDocument/2006/relationships" id="2147483649" r:id="R27525ccc1f024fe0"/>
+    <p:sldLayoutId xmlns:r="http://schemas.openxmlformats.org/officeDocument/2006/relationships" id="2147483649" r:id="R5fcd537a192742aa"/>
   </p:sldLayoutIdLst>
   <p:txStyles>
     <p:titleStyle>
@@ -1353,7 +1353,7 @@
           <p:cNvPr id="1" name="hero-green-rail">
             <a:extLst xmlns:a="http://schemas.openxmlformats.org/drawingml/2006/main">
               <a:ext uri="{FF2B5EF4-FFF2-40B4-BE49-F238E27FC236}">
-                <a16:creationId xmlns:a16="http://schemas.microsoft.com/office/drawing/2014/main" id="{D93701E0-CBEA-49B4-8FFE-11B2EA4CAA01}"/>
+                <a16:creationId xmlns:a16="http://schemas.microsoft.com/office/drawing/2014/main" id="{715A7F89-8B6E-4C48-A12C-9477C27E53BF}"/>
               </a:ext>
             </a:extLst>
           </p:cNvPr>
@@ -1384,7 +1384,7 @@
           <p:cNvPr id="2" name="">
             <a:extLst xmlns:a="http://schemas.openxmlformats.org/drawingml/2006/main">
               <a:ext uri="{FF2B5EF4-FFF2-40B4-BE49-F238E27FC236}">
-                <a16:creationId xmlns:a16="http://schemas.microsoft.com/office/drawing/2014/main" id="{EC6D386E-3C69-4B90-92B7-BED5AA16FB7F}"/>
+                <a16:creationId xmlns:a16="http://schemas.microsoft.com/office/drawing/2014/main" id="{742BFE92-3749-4EE3-9A96-106404D39083}"/>
               </a:ext>
             </a:extLst>
           </p:cNvPr>
@@ -1442,7 +1442,7 @@
           <p:cNvPr id="3" name="">
             <a:extLst xmlns:a="http://schemas.openxmlformats.org/drawingml/2006/main">
               <a:ext uri="{FF2B5EF4-FFF2-40B4-BE49-F238E27FC236}">
-                <a16:creationId xmlns:a16="http://schemas.microsoft.com/office/drawing/2014/main" id="{7E047001-02C9-4147-BF4D-41B48E4A61CB}"/>
+                <a16:creationId xmlns:a16="http://schemas.microsoft.com/office/drawing/2014/main" id="{5D7C8B84-CD0C-41D0-B518-2FFD4D97DD55}"/>
               </a:ext>
             </a:extLst>
           </p:cNvPr>
@@ -1531,7 +1531,7 @@
           <p:cNvPr id="4" name="">
             <a:extLst xmlns:a="http://schemas.openxmlformats.org/drawingml/2006/main">
               <a:ext uri="{FF2B5EF4-FFF2-40B4-BE49-F238E27FC236}">
-                <a16:creationId xmlns:a16="http://schemas.microsoft.com/office/drawing/2014/main" id="{3FB49136-1BA3-40E7-81F6-D341E1B37824}"/>
+                <a16:creationId xmlns:a16="http://schemas.microsoft.com/office/drawing/2014/main" id="{D23C7564-A431-4743-8EB4-CFC9657A99E8}"/>
               </a:ext>
             </a:extLst>
           </p:cNvPr>
@@ -1620,7 +1620,7 @@
           <p:cNvPr id="5" name="">
             <a:extLst xmlns:a="http://schemas.openxmlformats.org/drawingml/2006/main">
               <a:ext uri="{FF2B5EF4-FFF2-40B4-BE49-F238E27FC236}">
-                <a16:creationId xmlns:a16="http://schemas.microsoft.com/office/drawing/2014/main" id="{547AA1F6-2EE3-4685-823A-F66841E2B8E0}"/>
+                <a16:creationId xmlns:a16="http://schemas.microsoft.com/office/drawing/2014/main" id="{96B6DDA6-7B7F-4006-B5F3-CD57A30854E5}"/>
               </a:ext>
             </a:extLst>
           </p:cNvPr>
@@ -1682,7 +1682,7 @@
           <p:cNvPr id="6" name="">
             <a:extLst xmlns:a="http://schemas.openxmlformats.org/drawingml/2006/main">
               <a:ext uri="{FF2B5EF4-FFF2-40B4-BE49-F238E27FC236}">
-                <a16:creationId xmlns:a16="http://schemas.microsoft.com/office/drawing/2014/main" id="{37F5DE24-A47A-48A0-B390-D25E3D3B91BC}"/>
+                <a16:creationId xmlns:a16="http://schemas.microsoft.com/office/drawing/2014/main" id="{FDF9D9EC-E3EA-46B1-8621-F7A59DA3E977}"/>
               </a:ext>
             </a:extLst>
           </p:cNvPr>
@@ -1744,7 +1744,7 @@
           <p:cNvPr id="7" name="">
             <a:extLst xmlns:a="http://schemas.openxmlformats.org/drawingml/2006/main">
               <a:ext uri="{FF2B5EF4-FFF2-40B4-BE49-F238E27FC236}">
-                <a16:creationId xmlns:a16="http://schemas.microsoft.com/office/drawing/2014/main" id="{BA67135A-37EF-46A3-A852-701C0CAEE569}"/>
+                <a16:creationId xmlns:a16="http://schemas.microsoft.com/office/drawing/2014/main" id="{AF5CBECA-B1EC-4B64-ABB8-109C3D706F81}"/>
               </a:ext>
             </a:extLst>
           </p:cNvPr>
@@ -1806,7 +1806,7 @@
           <p:cNvPr id="8" name="hero-screen-frame">
             <a:extLst xmlns:a="http://schemas.openxmlformats.org/drawingml/2006/main">
               <a:ext uri="{FF2B5EF4-FFF2-40B4-BE49-F238E27FC236}">
-                <a16:creationId xmlns:a16="http://schemas.microsoft.com/office/drawing/2014/main" id="{A1A5EA84-27AB-4709-AB40-0A7DF67BDE31}"/>
+                <a16:creationId xmlns:a16="http://schemas.microsoft.com/office/drawing/2014/main" id="{C882432D-AB74-4EA2-A804-716F870FC69F}"/>
               </a:ext>
             </a:extLst>
           </p:cNvPr>
@@ -1851,7 +1851,7 @@
           <p:nvPr/>
         </p:nvPicPr>
         <p:blipFill>
-          <a:blip xmlns:r="http://schemas.openxmlformats.org/officeDocument/2006/relationships" xmlns:a="http://schemas.openxmlformats.org/drawingml/2006/main" r:embed="R111459d092fb4af9"/>
+          <a:blip xmlns:r="http://schemas.openxmlformats.org/officeDocument/2006/relationships" xmlns:a="http://schemas.openxmlformats.org/drawingml/2006/main" r:embed="Rfddea8612dba40f0"/>
           <a:srcRect xmlns:a="http://schemas.openxmlformats.org/drawingml/2006/main" l="8824" t="0" r="8824" b="0"/>
           <a:stretch xmlns:a="http://schemas.openxmlformats.org/drawingml/2006/main">
             <a:fillRect l="0" t="0" r="0" b="0"/>
@@ -1874,7 +1874,7 @@
           <p:cNvPr id="10" name="">
             <a:extLst xmlns:a="http://schemas.openxmlformats.org/drawingml/2006/main">
               <a:ext uri="{FF2B5EF4-FFF2-40B4-BE49-F238E27FC236}">
-                <a16:creationId xmlns:a16="http://schemas.microsoft.com/office/drawing/2014/main" id="{3024ADDD-654C-47FE-A381-A7E1970C28A4}"/>
+                <a16:creationId xmlns:a16="http://schemas.microsoft.com/office/drawing/2014/main" id="{7080D717-9387-4D22-8516-DE026BA2F33F}"/>
               </a:ext>
             </a:extLst>
           </p:cNvPr>
@@ -1936,7 +1936,7 @@
           <p:cNvPr id="11" name="">
             <a:extLst xmlns:a="http://schemas.openxmlformats.org/drawingml/2006/main">
               <a:ext uri="{FF2B5EF4-FFF2-40B4-BE49-F238E27FC236}">
-                <a16:creationId xmlns:a16="http://schemas.microsoft.com/office/drawing/2014/main" id="{2D0ED2D7-E75F-46F5-BB93-160520D05AE0}"/>
+                <a16:creationId xmlns:a16="http://schemas.microsoft.com/office/drawing/2014/main" id="{F4E3E705-3B36-4917-BEC6-E3B62477D1C1}"/>
               </a:ext>
             </a:extLst>
           </p:cNvPr>
@@ -1994,7 +1994,7 @@
           <p:cNvPr id="12" name="">
             <a:extLst xmlns:a="http://schemas.openxmlformats.org/drawingml/2006/main">
               <a:ext uri="{FF2B5EF4-FFF2-40B4-BE49-F238E27FC236}">
-                <a16:creationId xmlns:a16="http://schemas.microsoft.com/office/drawing/2014/main" id="{D5B51B94-0510-4251-84B8-3576395D7C2B}"/>
+                <a16:creationId xmlns:a16="http://schemas.microsoft.com/office/drawing/2014/main" id="{F1E56CE7-445D-400B-AFD3-385F1AA77EEF}"/>
               </a:ext>
             </a:extLst>
           </p:cNvPr>
@@ -2052,7 +2052,7 @@
           <p:cNvPr id="13" name="">
             <a:extLst xmlns:a="http://schemas.openxmlformats.org/drawingml/2006/main">
               <a:ext uri="{FF2B5EF4-FFF2-40B4-BE49-F238E27FC236}">
-                <a16:creationId xmlns:a16="http://schemas.microsoft.com/office/drawing/2014/main" id="{6EF831D5-3704-4E59-BBBF-62FE480D7DEA}"/>
+                <a16:creationId xmlns:a16="http://schemas.microsoft.com/office/drawing/2014/main" id="{16ECB8D8-7D45-4C6D-917C-7289AC26990C}"/>
               </a:ext>
             </a:extLst>
           </p:cNvPr>
@@ -2108,7 +2108,7 @@
     </p:spTree>
     <p:extLst>
       <p:ext uri="{BB962C8B-B14F-4D97-AF65-F5344CB8AC3E}">
-        <p14:creationId xmlns:p14="http://schemas.microsoft.com/office/powerpoint/2010/main" val="834669126"/>
+        <p14:creationId xmlns:p14="http://schemas.microsoft.com/office/powerpoint/2010/main" val="665642073"/>
       </p:ext>
     </p:extLst>
   </p:cSld>
@@ -2139,7 +2139,7 @@
           <p:cNvPr id="1" name="">
             <a:extLst xmlns:a="http://schemas.openxmlformats.org/drawingml/2006/main">
               <a:ext uri="{FF2B5EF4-FFF2-40B4-BE49-F238E27FC236}">
-                <a16:creationId xmlns:a16="http://schemas.microsoft.com/office/drawing/2014/main" id="{40314E5A-8585-4A7B-BA08-56C0678C374D}"/>
+                <a16:creationId xmlns:a16="http://schemas.microsoft.com/office/drawing/2014/main" id="{6FD67844-9305-4535-945F-418B90AB74DB}"/>
               </a:ext>
             </a:extLst>
           </p:cNvPr>
@@ -2197,7 +2197,7 @@
           <p:cNvPr id="2" name="">
             <a:extLst xmlns:a="http://schemas.openxmlformats.org/drawingml/2006/main">
               <a:ext uri="{FF2B5EF4-FFF2-40B4-BE49-F238E27FC236}">
-                <a16:creationId xmlns:a16="http://schemas.microsoft.com/office/drawing/2014/main" id="{6A19594F-FF20-45FC-B7A4-B32710C87D80}"/>
+                <a16:creationId xmlns:a16="http://schemas.microsoft.com/office/drawing/2014/main" id="{E3D68F54-1404-4690-814D-ECA5D04B84FE}"/>
               </a:ext>
             </a:extLst>
           </p:cNvPr>
@@ -2255,7 +2255,7 @@
           <p:cNvPr id="3" name="">
             <a:extLst xmlns:a="http://schemas.openxmlformats.org/drawingml/2006/main">
               <a:ext uri="{FF2B5EF4-FFF2-40B4-BE49-F238E27FC236}">
-                <a16:creationId xmlns:a16="http://schemas.microsoft.com/office/drawing/2014/main" id="{3E0B0171-2CF2-4E28-8CC9-0AD701E27DEE}"/>
+                <a16:creationId xmlns:a16="http://schemas.microsoft.com/office/drawing/2014/main" id="{98EA8FE3-F9F3-42D4-8EF0-D08C1310EEFE}"/>
               </a:ext>
             </a:extLst>
           </p:cNvPr>
@@ -2348,7 +2348,7 @@
           <p:cNvPr id="4" name="">
             <a:extLst xmlns:a="http://schemas.openxmlformats.org/drawingml/2006/main">
               <a:ext uri="{FF2B5EF4-FFF2-40B4-BE49-F238E27FC236}">
-                <a16:creationId xmlns:a16="http://schemas.microsoft.com/office/drawing/2014/main" id="{B96A5C65-DBAB-4C6E-920A-B86156203AA5}"/>
+                <a16:creationId xmlns:a16="http://schemas.microsoft.com/office/drawing/2014/main" id="{0D084CBE-2127-4F5C-B321-82E2D235F60D}"/>
               </a:ext>
             </a:extLst>
           </p:cNvPr>
@@ -2441,7 +2441,7 @@
           <p:cNvPr id="5" name="">
             <a:extLst xmlns:a="http://schemas.openxmlformats.org/drawingml/2006/main">
               <a:ext uri="{FF2B5EF4-FFF2-40B4-BE49-F238E27FC236}">
-                <a16:creationId xmlns:a16="http://schemas.microsoft.com/office/drawing/2014/main" id="{3C644DD6-3B2C-4BDB-80FA-8A54E69A9A9B}"/>
+                <a16:creationId xmlns:a16="http://schemas.microsoft.com/office/drawing/2014/main" id="{974BD9A9-2FE6-4244-9AD0-2C61B37D9CD9}"/>
               </a:ext>
             </a:extLst>
           </p:cNvPr>
@@ -2557,7 +2557,7 @@
           <p:cNvPr id="6" name="">
             <a:extLst xmlns:a="http://schemas.openxmlformats.org/drawingml/2006/main">
               <a:ext uri="{FF2B5EF4-FFF2-40B4-BE49-F238E27FC236}">
-                <a16:creationId xmlns:a16="http://schemas.microsoft.com/office/drawing/2014/main" id="{4591154B-EFC7-404F-A3CE-062D992D29BD}"/>
+                <a16:creationId xmlns:a16="http://schemas.microsoft.com/office/drawing/2014/main" id="{F9987B6D-901C-4E37-B2A3-86CD8D5D79BF}"/>
               </a:ext>
             </a:extLst>
           </p:cNvPr>
@@ -2644,7 +2644,7 @@
           <p:cNvPr id="7" name="">
             <a:extLst xmlns:a="http://schemas.openxmlformats.org/drawingml/2006/main">
               <a:ext uri="{FF2B5EF4-FFF2-40B4-BE49-F238E27FC236}">
-                <a16:creationId xmlns:a16="http://schemas.microsoft.com/office/drawing/2014/main" id="{D9CAFEAC-72D4-468B-89D8-0FCF6B9CDF72}"/>
+                <a16:creationId xmlns:a16="http://schemas.microsoft.com/office/drawing/2014/main" id="{88A3AB20-1B79-485E-BE15-1AE062FE3994}"/>
               </a:ext>
             </a:extLst>
           </p:cNvPr>
@@ -2867,7 +2867,7 @@
           <p:cNvPr id="13" name="">
             <a:extLst xmlns:a="http://schemas.openxmlformats.org/drawingml/2006/main">
               <a:ext uri="{FF2B5EF4-FFF2-40B4-BE49-F238E27FC236}">
-                <a16:creationId xmlns:a16="http://schemas.microsoft.com/office/drawing/2014/main" id="{57336137-AF42-4A6F-B358-1EECE5892778}"/>
+                <a16:creationId xmlns:a16="http://schemas.microsoft.com/office/drawing/2014/main" id="{BD150A0A-CE93-4C2D-854F-12FF2D929508}"/>
               </a:ext>
             </a:extLst>
           </p:cNvPr>
@@ -2929,7 +2929,7 @@
           <p:cNvPr id="14" name="">
             <a:extLst xmlns:a="http://schemas.openxmlformats.org/drawingml/2006/main">
               <a:ext uri="{FF2B5EF4-FFF2-40B4-BE49-F238E27FC236}">
-                <a16:creationId xmlns:a16="http://schemas.microsoft.com/office/drawing/2014/main" id="{E59F270E-D047-4681-AA11-AC3F844DE945}"/>
+                <a16:creationId xmlns:a16="http://schemas.microsoft.com/office/drawing/2014/main" id="{0F0BBC2D-EDC2-473C-B9EE-1661E7FE47C4}"/>
               </a:ext>
             </a:extLst>
           </p:cNvPr>
@@ -2987,7 +2987,7 @@
           <p:cNvPr id="15" name="">
             <a:extLst xmlns:a="http://schemas.openxmlformats.org/drawingml/2006/main">
               <a:ext uri="{FF2B5EF4-FFF2-40B4-BE49-F238E27FC236}">
-                <a16:creationId xmlns:a16="http://schemas.microsoft.com/office/drawing/2014/main" id="{47118873-C721-4A71-9824-20B6BDC45E36}"/>
+                <a16:creationId xmlns:a16="http://schemas.microsoft.com/office/drawing/2014/main" id="{7A5C1848-6AA0-4D9B-9360-8D56CC282543}"/>
               </a:ext>
             </a:extLst>
           </p:cNvPr>
@@ -3045,7 +3045,7 @@
           <p:cNvPr id="16" name="">
             <a:extLst xmlns:a="http://schemas.openxmlformats.org/drawingml/2006/main">
               <a:ext uri="{FF2B5EF4-FFF2-40B4-BE49-F238E27FC236}">
-                <a16:creationId xmlns:a16="http://schemas.microsoft.com/office/drawing/2014/main" id="{514DCD70-15D3-4ADA-8BF9-83868F2FDDC4}"/>
+                <a16:creationId xmlns:a16="http://schemas.microsoft.com/office/drawing/2014/main" id="{A7C5978E-F92A-4E2A-9EC3-F3B9FEAC17B4}"/>
               </a:ext>
             </a:extLst>
           </p:cNvPr>
@@ -3101,7 +3101,7 @@
     </p:spTree>
     <p:extLst>
       <p:ext uri="{BB962C8B-B14F-4D97-AF65-F5344CB8AC3E}">
-        <p14:creationId xmlns:p14="http://schemas.microsoft.com/office/powerpoint/2010/main" val="1560112400"/>
+        <p14:creationId xmlns:p14="http://schemas.microsoft.com/office/powerpoint/2010/main" val="1116232740"/>
       </p:ext>
     </p:extLst>
   </p:cSld>
@@ -3132,7 +3132,7 @@
           <p:cNvPr id="1" name="">
             <a:extLst xmlns:a="http://schemas.openxmlformats.org/drawingml/2006/main">
               <a:ext uri="{FF2B5EF4-FFF2-40B4-BE49-F238E27FC236}">
-                <a16:creationId xmlns:a16="http://schemas.microsoft.com/office/drawing/2014/main" id="{7429AB97-2A1E-4912-A84F-A47E6D704E79}"/>
+                <a16:creationId xmlns:a16="http://schemas.microsoft.com/office/drawing/2014/main" id="{E7EFC706-A133-4E45-A559-3F9D359BCFAD}"/>
               </a:ext>
             </a:extLst>
           </p:cNvPr>
@@ -3190,7 +3190,7 @@
           <p:cNvPr id="2" name="">
             <a:extLst xmlns:a="http://schemas.openxmlformats.org/drawingml/2006/main">
               <a:ext uri="{FF2B5EF4-FFF2-40B4-BE49-F238E27FC236}">
-                <a16:creationId xmlns:a16="http://schemas.microsoft.com/office/drawing/2014/main" id="{B555E1CB-E573-4996-A939-751B75D0CC18}"/>
+                <a16:creationId xmlns:a16="http://schemas.microsoft.com/office/drawing/2014/main" id="{CBDB5DB5-FC6D-4312-ACBD-F8A069D42AAC}"/>
               </a:ext>
             </a:extLst>
           </p:cNvPr>
@@ -3248,7 +3248,7 @@
           <p:cNvPr id="3" name="">
             <a:extLst xmlns:a="http://schemas.openxmlformats.org/drawingml/2006/main">
               <a:ext uri="{FF2B5EF4-FFF2-40B4-BE49-F238E27FC236}">
-                <a16:creationId xmlns:a16="http://schemas.microsoft.com/office/drawing/2014/main" id="{2D7E1F9E-2FC0-43CC-8502-E67AFE06DA3D}"/>
+                <a16:creationId xmlns:a16="http://schemas.microsoft.com/office/drawing/2014/main" id="{66942125-BA4D-4EB1-9020-9FD612BCA370}"/>
               </a:ext>
             </a:extLst>
           </p:cNvPr>
@@ -3369,7 +3369,7 @@
           <p:cNvPr id="4" name="">
             <a:extLst xmlns:a="http://schemas.openxmlformats.org/drawingml/2006/main">
               <a:ext uri="{FF2B5EF4-FFF2-40B4-BE49-F238E27FC236}">
-                <a16:creationId xmlns:a16="http://schemas.microsoft.com/office/drawing/2014/main" id="{D68C01D0-65B3-42FE-B741-81393C1AE714}"/>
+                <a16:creationId xmlns:a16="http://schemas.microsoft.com/office/drawing/2014/main" id="{7A64F205-A4C5-41F1-9944-86E1C309B22B}"/>
               </a:ext>
             </a:extLst>
           </p:cNvPr>
@@ -3490,7 +3490,7 @@
           <p:cNvPr id="5" name="">
             <a:extLst xmlns:a="http://schemas.openxmlformats.org/drawingml/2006/main">
               <a:ext uri="{FF2B5EF4-FFF2-40B4-BE49-F238E27FC236}">
-                <a16:creationId xmlns:a16="http://schemas.microsoft.com/office/drawing/2014/main" id="{075A2DD0-66B6-4191-9649-6D8A21DCA4DF}"/>
+                <a16:creationId xmlns:a16="http://schemas.microsoft.com/office/drawing/2014/main" id="{6782B80A-FC0A-4BC2-8CA5-4677C03A3E74}"/>
               </a:ext>
             </a:extLst>
           </p:cNvPr>
@@ -3663,7 +3663,7 @@
           <p:cNvPr id="8" name="">
             <a:extLst xmlns:a="http://schemas.openxmlformats.org/drawingml/2006/main">
               <a:ext uri="{FF2B5EF4-FFF2-40B4-BE49-F238E27FC236}">
-                <a16:creationId xmlns:a16="http://schemas.microsoft.com/office/drawing/2014/main" id="{53AC3B50-D233-4567-9679-B55A847DDC3D}"/>
+                <a16:creationId xmlns:a16="http://schemas.microsoft.com/office/drawing/2014/main" id="{395EBBB9-A0EF-4FA2-B0F1-E458FDD7AB14}"/>
               </a:ext>
             </a:extLst>
           </p:cNvPr>
@@ -3725,7 +3725,7 @@
           <p:cNvPr id="9" name="">
             <a:extLst xmlns:a="http://schemas.openxmlformats.org/drawingml/2006/main">
               <a:ext uri="{FF2B5EF4-FFF2-40B4-BE49-F238E27FC236}">
-                <a16:creationId xmlns:a16="http://schemas.microsoft.com/office/drawing/2014/main" id="{B0F11D9A-60E3-4C78-A98C-17AD5F7895B7}"/>
+                <a16:creationId xmlns:a16="http://schemas.microsoft.com/office/drawing/2014/main" id="{0E85C9FF-0356-42AA-A608-8FF8D9ECFB7E}"/>
               </a:ext>
             </a:extLst>
           </p:cNvPr>
@@ -3787,7 +3787,7 @@
           <p:cNvPr id="10" name="">
             <a:extLst xmlns:a="http://schemas.openxmlformats.org/drawingml/2006/main">
               <a:ext uri="{FF2B5EF4-FFF2-40B4-BE49-F238E27FC236}">
-                <a16:creationId xmlns:a16="http://schemas.microsoft.com/office/drawing/2014/main" id="{3702A585-FE4B-4C9C-A9F3-596AC7E07BCD}"/>
+                <a16:creationId xmlns:a16="http://schemas.microsoft.com/office/drawing/2014/main" id="{D2ACAA6F-61DD-4A43-920D-BECCF10D77C5}"/>
               </a:ext>
             </a:extLst>
           </p:cNvPr>
@@ -3849,7 +3849,7 @@
           <p:cNvPr id="11" name="">
             <a:extLst xmlns:a="http://schemas.openxmlformats.org/drawingml/2006/main">
               <a:ext uri="{FF2B5EF4-FFF2-40B4-BE49-F238E27FC236}">
-                <a16:creationId xmlns:a16="http://schemas.microsoft.com/office/drawing/2014/main" id="{60BDF578-039F-4A82-BC75-A275F819A8BA}"/>
+                <a16:creationId xmlns:a16="http://schemas.microsoft.com/office/drawing/2014/main" id="{4F41468A-9631-4E5B-8C44-5D623353FBE7}"/>
               </a:ext>
             </a:extLst>
           </p:cNvPr>
@@ -3913,7 +3913,7 @@
           <p:cNvPr id="12" name="">
             <a:extLst xmlns:a="http://schemas.openxmlformats.org/drawingml/2006/main">
               <a:ext uri="{FF2B5EF4-FFF2-40B4-BE49-F238E27FC236}">
-                <a16:creationId xmlns:a16="http://schemas.microsoft.com/office/drawing/2014/main" id="{0969B733-D84B-454A-BC2E-5D83B9B37714}"/>
+                <a16:creationId xmlns:a16="http://schemas.microsoft.com/office/drawing/2014/main" id="{45808490-8488-4249-8CA9-476698463569}"/>
               </a:ext>
             </a:extLst>
           </p:cNvPr>
@@ -3971,7 +3971,7 @@
           <p:cNvPr id="13" name="">
             <a:extLst xmlns:a="http://schemas.openxmlformats.org/drawingml/2006/main">
               <a:ext uri="{FF2B5EF4-FFF2-40B4-BE49-F238E27FC236}">
-                <a16:creationId xmlns:a16="http://schemas.microsoft.com/office/drawing/2014/main" id="{657FF042-20D5-4D3B-8D2A-1C698AE405A9}"/>
+                <a16:creationId xmlns:a16="http://schemas.microsoft.com/office/drawing/2014/main" id="{BAD4CD59-6391-478A-BC3C-21708677E7BC}"/>
               </a:ext>
             </a:extLst>
           </p:cNvPr>
@@ -4027,7 +4027,7 @@
     </p:spTree>
     <p:extLst>
       <p:ext uri="{BB962C8B-B14F-4D97-AF65-F5344CB8AC3E}">
-        <p14:creationId xmlns:p14="http://schemas.microsoft.com/office/powerpoint/2010/main" val="4885466"/>
+        <p14:creationId xmlns:p14="http://schemas.microsoft.com/office/powerpoint/2010/main" val="661292676"/>
       </p:ext>
     </p:extLst>
   </p:cSld>
@@ -4058,7 +4058,7 @@
           <p:cNvPr id="1" name="">
             <a:extLst xmlns:a="http://schemas.openxmlformats.org/drawingml/2006/main">
               <a:ext uri="{FF2B5EF4-FFF2-40B4-BE49-F238E27FC236}">
-                <a16:creationId xmlns:a16="http://schemas.microsoft.com/office/drawing/2014/main" id="{B4DD44C5-C9EB-4BD5-AA38-54D6831224E3}"/>
+                <a16:creationId xmlns:a16="http://schemas.microsoft.com/office/drawing/2014/main" id="{BEBD0CDB-ED7B-4763-B25B-11D896AAF6D0}"/>
               </a:ext>
             </a:extLst>
           </p:cNvPr>
@@ -4070,7 +4070,7 @@
         <p:spPr>
           <a:xfrm xmlns:a="http://schemas.openxmlformats.org/drawingml/2006/main">
             <a:off x="323850" y="228600"/>
-            <a:ext cx="7429500" cy="438150"/>
+            <a:ext cx="8096250" cy="438150"/>
           </a:xfrm>
           <a:prstGeom xmlns:a="http://schemas.openxmlformats.org/drawingml/2006/main" prst="rect">
             <a:avLst/>
@@ -4106,7 +4106,7 @@
                 <a:ea typeface="Noto Sans JP Thin"/>
                 <a:cs typeface="Noto Sans JP Thin"/>
               </a:rPr>
-              <a:t>専門判断をDevOpsする、2つのループ</a:t>
+              <a:t>相続の盾｜専門判断を安全に運用する仕組み</a:t>
             </a:r>
           </a:p>
         </p:txBody>
@@ -4116,7 +4116,7 @@
           <p:cNvPr id="2" name="">
             <a:extLst xmlns:a="http://schemas.openxmlformats.org/drawingml/2006/main">
               <a:ext uri="{FF2B5EF4-FFF2-40B4-BE49-F238E27FC236}">
-                <a16:creationId xmlns:a16="http://schemas.microsoft.com/office/drawing/2014/main" id="{FF0EF5E0-A3AC-44DA-8931-6E0178FB79BD}"/>
+                <a16:creationId xmlns:a16="http://schemas.microsoft.com/office/drawing/2014/main" id="{5000DCB3-B5F0-4258-96C1-45F556AA9202}"/>
               </a:ext>
             </a:extLst>
           </p:cNvPr>
@@ -4146,7 +4146,7 @@
           <a:lstStyle xmlns:a="http://schemas.openxmlformats.org/drawingml/2006/main"/>
           <a:p xmlns:a="http://schemas.openxmlformats.org/drawingml/2006/main">
             <a:pPr algn="l">
-              <a:defRPr sz="1200" b="1">
+              <a:defRPr sz="1275" b="0">
                 <a:solidFill>
                   <a:srgbClr val="5F6D7A"/>
                 </a:solidFill>
@@ -4156,7 +4156,7 @@
               </a:defRPr>
             </a:pPr>
             <a:r>
-              <a:rPr sz="1200" b="1">
+              <a:rPr sz="1275" b="0">
                 <a:solidFill>
                   <a:srgbClr val="5F6D7A"/>
                 </a:solidFill>
@@ -4164,17 +4164,17 @@
                 <a:ea typeface="Noto Sans JP Thin"/>
                 <a:cs typeface="Noto Sans JP Thin"/>
               </a:rPr>
-              <a:t>AI＝進むか聞くか  ｜  CODE＝再現可能な要件整理  ｜  HUMAN＝可否判断と承認</a:t>
-            </a:r>
-          </a:p>
-        </p:txBody>
-      </p:sp>
-      <p:sp>
-        <p:nvSpPr>
-          <p:cNvPr id="3" name="runtime-lane">
-            <a:extLst xmlns:a="http://schemas.openxmlformats.org/drawingml/2006/main">
-              <a:ext uri="{FF2B5EF4-FFF2-40B4-BE49-F238E27FC236}">
-                <a16:creationId xmlns:a16="http://schemas.microsoft.com/office/drawing/2014/main" id="{5CFC2156-4E98-4F59-8BC1-7326437EE8B3}"/>
+              <a:t>AIが次の行動を選び、コードが要件を再現し、税理士が最終判断します。</a:t>
+            </a:r>
+          </a:p>
+        </p:txBody>
+      </p:sp>
+      <p:sp>
+        <p:nvSpPr>
+          <p:cNvPr id="3" name="execution-lane">
+            <a:extLst xmlns:a="http://schemas.openxmlformats.org/drawingml/2006/main">
+              <a:ext uri="{FF2B5EF4-FFF2-40B4-BE49-F238E27FC236}">
+                <a16:creationId xmlns:a16="http://schemas.microsoft.com/office/drawing/2014/main" id="{D2C54E1C-1BD2-41D9-AAF1-A22A4D8374CA}"/>
               </a:ext>
             </a:extLst>
           </p:cNvPr>
@@ -4186,11 +4186,11 @@
         <p:spPr>
           <a:xfrm xmlns:a="http://schemas.openxmlformats.org/drawingml/2006/main">
             <a:off x="228600" y="1028700"/>
-            <a:ext cx="9296400" cy="2819400"/>
+            <a:ext cx="9296400" cy="2800350"/>
           </a:xfrm>
           <a:prstGeom xmlns:a="http://schemas.openxmlformats.org/drawingml/2006/main" prst="roundRect">
             <a:avLst>
-              <a:gd name="adj" fmla="val 5405"/>
+              <a:gd name="adj" fmla="val 5442"/>
             </a:avLst>
           </a:prstGeom>
           <a:solidFill xmlns:a="http://schemas.openxmlformats.org/drawingml/2006/main">
@@ -4209,7 +4209,7 @@
           <p:cNvPr id="4" name="devops-lane">
             <a:extLst xmlns:a="http://schemas.openxmlformats.org/drawingml/2006/main">
               <a:ext uri="{FF2B5EF4-FFF2-40B4-BE49-F238E27FC236}">
-                <a16:creationId xmlns:a16="http://schemas.microsoft.com/office/drawing/2014/main" id="{832E5FC0-87D7-4B45-A28D-777CCAE4DF93}"/>
+                <a16:creationId xmlns:a16="http://schemas.microsoft.com/office/drawing/2014/main" id="{7BE60A9C-CA52-4E8C-B7B0-44055A9CB353}"/>
               </a:ext>
             </a:extLst>
           </p:cNvPr>
@@ -4244,7 +4244,7 @@
           <p:cNvPr id="5" name="">
             <a:extLst xmlns:a="http://schemas.openxmlformats.org/drawingml/2006/main">
               <a:ext uri="{FF2B5EF4-FFF2-40B4-BE49-F238E27FC236}">
-                <a16:creationId xmlns:a16="http://schemas.microsoft.com/office/drawing/2014/main" id="{980D3C6B-EA4A-45B1-A415-3FE56B1DC0E4}"/>
+                <a16:creationId xmlns:a16="http://schemas.microsoft.com/office/drawing/2014/main" id="{A0E76717-80C1-46D3-BF22-9CE7520C1C13}"/>
               </a:ext>
             </a:extLst>
           </p:cNvPr>
@@ -4256,7 +4256,7 @@
         <p:spPr>
           <a:xfrm xmlns:a="http://schemas.openxmlformats.org/drawingml/2006/main">
             <a:off x="381000" y="1123950"/>
-            <a:ext cx="990600" cy="266700"/>
+            <a:ext cx="1066800" cy="266700"/>
           </a:xfrm>
           <a:prstGeom xmlns:a="http://schemas.openxmlformats.org/drawingml/2006/main" prst="roundRect">
             <a:avLst>
@@ -4296,7 +4296,7 @@
                 <a:ea typeface="Noto Sans JP Thin"/>
                 <a:cs typeface="Noto Sans JP Thin"/>
               </a:rPr>
-              <a:t>RUNTIME</a:t>
+              <a:t>実行の流れ</a:t>
             </a:r>
           </a:p>
         </p:txBody>
@@ -4306,7 +4306,7 @@
           <p:cNvPr id="6" name="">
             <a:extLst xmlns:a="http://schemas.openxmlformats.org/drawingml/2006/main">
               <a:ext uri="{FF2B5EF4-FFF2-40B4-BE49-F238E27FC236}">
-                <a16:creationId xmlns:a16="http://schemas.microsoft.com/office/drawing/2014/main" id="{F9A991FA-F7DA-40C0-8CBE-0A53CE4ACEF3}"/>
+                <a16:creationId xmlns:a16="http://schemas.microsoft.com/office/drawing/2014/main" id="{F8E47F21-903B-433A-8619-3CCCE4D9342B}"/>
               </a:ext>
             </a:extLst>
           </p:cNvPr>
@@ -4318,7 +4318,7 @@
         <p:spPr>
           <a:xfrm xmlns:a="http://schemas.openxmlformats.org/drawingml/2006/main">
             <a:off x="381000" y="4076700"/>
-            <a:ext cx="990600" cy="266700"/>
+            <a:ext cx="1066800" cy="266700"/>
           </a:xfrm>
           <a:prstGeom xmlns:a="http://schemas.openxmlformats.org/drawingml/2006/main" prst="roundRect">
             <a:avLst>
@@ -4358,33 +4358,902 @@
                 <a:ea typeface="Noto Sans JP Thin"/>
                 <a:cs typeface="Noto Sans JP Thin"/>
               </a:rPr>
-              <a:t>DEVOPS</a:t>
-            </a:r>
-          </a:p>
-        </p:txBody>
-      </p:sp>
-      <p:sp>
-        <p:nvSpPr>
-          <p:cNvPr id="7" name="">
-            <a:extLst xmlns:a="http://schemas.openxmlformats.org/drawingml/2006/main">
-              <a:ext uri="{FF2B5EF4-FFF2-40B4-BE49-F238E27FC236}">
-                <a16:creationId xmlns:a16="http://schemas.microsoft.com/office/drawing/2014/main" id="{C1B58882-E8AC-4B44-B3CD-97B027289823}"/>
-              </a:ext>
-            </a:extLst>
-          </p:cNvPr>
-          <p:cNvSpPr>
-            <a:spLocks xmlns:a="http://schemas.openxmlformats.org/drawingml/2006/main" noGrp="1"/>
-          </p:cNvSpPr>
-          <p:nvPr/>
-        </p:nvSpPr>
-        <p:spPr>
-          <a:xfrm xmlns:a="http://schemas.openxmlformats.org/drawingml/2006/main">
-            <a:off x="400050" y="1771650"/>
-            <a:ext cx="1104900" cy="1123950"/>
+              <a:t>継続改善</a:t>
+            </a:r>
+          </a:p>
+        </p:txBody>
+      </p:sp>
+      <p:sp>
+        <p:nvSpPr>
+          <p:cNvPr id="7" name="main-flow-arrow-180">
+            <a:extLst xmlns:a="http://schemas.openxmlformats.org/drawingml/2006/main">
+              <a:ext uri="{FF2B5EF4-FFF2-40B4-BE49-F238E27FC236}">
+                <a16:creationId xmlns:a16="http://schemas.microsoft.com/office/drawing/2014/main" id="{66604DCB-6E07-4CDC-B77F-6579C39A8780}"/>
+              </a:ext>
+            </a:extLst>
+          </p:cNvPr>
+          <p:cNvSpPr>
+            <a:spLocks xmlns:a="http://schemas.openxmlformats.org/drawingml/2006/main" noGrp="1"/>
+          </p:cNvSpPr>
+          <p:nvPr/>
+        </p:nvSpPr>
+        <p:spPr>
+          <a:xfrm xmlns:a="http://schemas.openxmlformats.org/drawingml/2006/main">
+            <a:off x="1714500" y="2038350"/>
+            <a:ext cx="247650" cy="171450"/>
+          </a:xfrm>
+          <a:prstGeom xmlns:a="http://schemas.openxmlformats.org/drawingml/2006/main" prst="rightArrow">
+            <a:avLst/>
+          </a:prstGeom>
+          <a:solidFill xmlns:a="http://schemas.openxmlformats.org/drawingml/2006/main">
+            <a:srgbClr val="15845C"/>
+          </a:solidFill>
+          <a:ln xmlns:a="http://schemas.openxmlformats.org/drawingml/2006/main" w="0">
+            <a:noFill/>
+            <a:prstDash val="solid"/>
+          </a:ln>
+        </p:spPr>
+      </p:sp>
+      <p:sp>
+        <p:nvSpPr>
+          <p:cNvPr id="8" name="main-flow-arrow-380">
+            <a:extLst xmlns:a="http://schemas.openxmlformats.org/drawingml/2006/main">
+              <a:ext uri="{FF2B5EF4-FFF2-40B4-BE49-F238E27FC236}">
+                <a16:creationId xmlns:a16="http://schemas.microsoft.com/office/drawing/2014/main" id="{69DF6A23-D5CE-46A5-BC6B-90CCD70AA36D}"/>
+              </a:ext>
+            </a:extLst>
+          </p:cNvPr>
+          <p:cNvSpPr>
+            <a:spLocks xmlns:a="http://schemas.openxmlformats.org/drawingml/2006/main" noGrp="1"/>
+          </p:cNvSpPr>
+          <p:nvPr/>
+        </p:nvSpPr>
+        <p:spPr>
+          <a:xfrm xmlns:a="http://schemas.openxmlformats.org/drawingml/2006/main">
+            <a:off x="3619500" y="2038350"/>
+            <a:ext cx="247650" cy="171450"/>
+          </a:xfrm>
+          <a:prstGeom xmlns:a="http://schemas.openxmlformats.org/drawingml/2006/main" prst="rightArrow">
+            <a:avLst/>
+          </a:prstGeom>
+          <a:solidFill xmlns:a="http://schemas.openxmlformats.org/drawingml/2006/main">
+            <a:srgbClr val="15845C"/>
+          </a:solidFill>
+          <a:ln xmlns:a="http://schemas.openxmlformats.org/drawingml/2006/main" w="0">
+            <a:noFill/>
+            <a:prstDash val="solid"/>
+          </a:ln>
+        </p:spPr>
+      </p:sp>
+      <p:sp>
+        <p:nvSpPr>
+          <p:cNvPr id="9" name="main-flow-arrow-612">
+            <a:extLst xmlns:a="http://schemas.openxmlformats.org/drawingml/2006/main">
+              <a:ext uri="{FF2B5EF4-FFF2-40B4-BE49-F238E27FC236}">
+                <a16:creationId xmlns:a16="http://schemas.microsoft.com/office/drawing/2014/main" id="{B84A63A1-5137-4E66-83C8-5D5E57BDBF2F}"/>
+              </a:ext>
+            </a:extLst>
+          </p:cNvPr>
+          <p:cNvSpPr>
+            <a:spLocks xmlns:a="http://schemas.openxmlformats.org/drawingml/2006/main" noGrp="1"/>
+          </p:cNvSpPr>
+          <p:nvPr/>
+        </p:nvSpPr>
+        <p:spPr>
+          <a:xfrm xmlns:a="http://schemas.openxmlformats.org/drawingml/2006/main">
+            <a:off x="5829300" y="2038350"/>
+            <a:ext cx="247650" cy="171450"/>
+          </a:xfrm>
+          <a:prstGeom xmlns:a="http://schemas.openxmlformats.org/drawingml/2006/main" prst="rightArrow">
+            <a:avLst/>
+          </a:prstGeom>
+          <a:solidFill xmlns:a="http://schemas.openxmlformats.org/drawingml/2006/main">
+            <a:srgbClr val="15845C"/>
+          </a:solidFill>
+          <a:ln xmlns:a="http://schemas.openxmlformats.org/drawingml/2006/main" w="0">
+            <a:noFill/>
+            <a:prstDash val="solid"/>
+          </a:ln>
+        </p:spPr>
+      </p:sp>
+      <p:sp>
+        <p:nvSpPr>
+          <p:cNvPr id="10" name="main-flow-arrow-820">
+            <a:extLst xmlns:a="http://schemas.openxmlformats.org/drawingml/2006/main">
+              <a:ext uri="{FF2B5EF4-FFF2-40B4-BE49-F238E27FC236}">
+                <a16:creationId xmlns:a16="http://schemas.microsoft.com/office/drawing/2014/main" id="{82DE4551-E229-424A-9E03-4A6BB761307F}"/>
+              </a:ext>
+            </a:extLst>
+          </p:cNvPr>
+          <p:cNvSpPr>
+            <a:spLocks xmlns:a="http://schemas.openxmlformats.org/drawingml/2006/main" noGrp="1"/>
+          </p:cNvSpPr>
+          <p:nvPr/>
+        </p:nvSpPr>
+        <p:spPr>
+          <a:xfrm xmlns:a="http://schemas.openxmlformats.org/drawingml/2006/main">
+            <a:off x="7810500" y="2038350"/>
+            <a:ext cx="247650" cy="171450"/>
+          </a:xfrm>
+          <a:prstGeom xmlns:a="http://schemas.openxmlformats.org/drawingml/2006/main" prst="rightArrow">
+            <a:avLst/>
+          </a:prstGeom>
+          <a:solidFill xmlns:a="http://schemas.openxmlformats.org/drawingml/2006/main">
+            <a:srgbClr val="C25B24"/>
+          </a:solidFill>
+          <a:ln xmlns:a="http://schemas.openxmlformats.org/drawingml/2006/main" w="0">
+            <a:noFill/>
+            <a:prstDash val="solid"/>
+          </a:ln>
+        </p:spPr>
+      </p:sp>
+      <p:sp>
+        <p:nvSpPr>
+          <p:cNvPr id="11" name="safe-stop-down">
+            <a:extLst xmlns:a="http://schemas.openxmlformats.org/drawingml/2006/main">
+              <a:ext uri="{FF2B5EF4-FFF2-40B4-BE49-F238E27FC236}">
+                <a16:creationId xmlns:a16="http://schemas.microsoft.com/office/drawing/2014/main" id="{8D9E6922-346D-4F1B-9564-A51CCDA615FF}"/>
+              </a:ext>
+            </a:extLst>
+          </p:cNvPr>
+          <p:cNvSpPr>
+            <a:spLocks xmlns:a="http://schemas.openxmlformats.org/drawingml/2006/main" noGrp="1"/>
+          </p:cNvSpPr>
+          <p:nvPr/>
+        </p:nvSpPr>
+        <p:spPr>
+          <a:xfrm xmlns:a="http://schemas.openxmlformats.org/drawingml/2006/main">
+            <a:off x="2571750" y="2686050"/>
+            <a:ext cx="209550" cy="247650"/>
+          </a:xfrm>
+          <a:prstGeom xmlns:a="http://schemas.openxmlformats.org/drawingml/2006/main" prst="downArrow">
+            <a:avLst/>
+          </a:prstGeom>
+          <a:solidFill xmlns:a="http://schemas.openxmlformats.org/drawingml/2006/main">
+            <a:srgbClr val="A66A00"/>
+          </a:solidFill>
+          <a:ln xmlns:a="http://schemas.openxmlformats.org/drawingml/2006/main" w="0">
+            <a:noFill/>
+            <a:prstDash val="solid"/>
+          </a:ln>
+        </p:spPr>
+      </p:sp>
+      <p:sp>
+        <p:nvSpPr>
+          <p:cNvPr id="12" name="safe-stop-resume">
+            <a:extLst xmlns:a="http://schemas.openxmlformats.org/drawingml/2006/main">
+              <a:ext uri="{FF2B5EF4-FFF2-40B4-BE49-F238E27FC236}">
+                <a16:creationId xmlns:a16="http://schemas.microsoft.com/office/drawing/2014/main" id="{6AFAA796-E3A5-400E-A553-B924BB3E172D}"/>
+              </a:ext>
+            </a:extLst>
+          </p:cNvPr>
+          <p:cNvSpPr>
+            <a:spLocks xmlns:a="http://schemas.openxmlformats.org/drawingml/2006/main" noGrp="1"/>
+          </p:cNvSpPr>
+          <p:nvPr/>
+        </p:nvSpPr>
+        <p:spPr>
+          <a:xfrm xmlns:a="http://schemas.openxmlformats.org/drawingml/2006/main">
+            <a:off x="3181350" y="2686050"/>
+            <a:ext cx="209550" cy="247650"/>
+          </a:xfrm>
+          <a:prstGeom xmlns:a="http://schemas.openxmlformats.org/drawingml/2006/main" prst="upArrow">
+            <a:avLst/>
+          </a:prstGeom>
+          <a:solidFill xmlns:a="http://schemas.openxmlformats.org/drawingml/2006/main">
+            <a:srgbClr val="A66A00"/>
+          </a:solidFill>
+          <a:ln xmlns:a="http://schemas.openxmlformats.org/drawingml/2006/main" w="0">
+            <a:noFill/>
+            <a:prstDash val="solid"/>
+          </a:ln>
+        </p:spPr>
+      </p:sp>
+      <p:sp>
+        <p:nvSpPr>
+          <p:cNvPr id="13" name="improvement-arrow-350">
+            <a:extLst xmlns:a="http://schemas.openxmlformats.org/drawingml/2006/main">
+              <a:ext uri="{FF2B5EF4-FFF2-40B4-BE49-F238E27FC236}">
+                <a16:creationId xmlns:a16="http://schemas.microsoft.com/office/drawing/2014/main" id="{49C7D865-B1A4-4ED8-AB5D-14119B411532}"/>
+              </a:ext>
+            </a:extLst>
+          </p:cNvPr>
+          <p:cNvSpPr>
+            <a:spLocks xmlns:a="http://schemas.openxmlformats.org/drawingml/2006/main" noGrp="1"/>
+          </p:cNvSpPr>
+          <p:nvPr/>
+        </p:nvSpPr>
+        <p:spPr>
+          <a:xfrm xmlns:a="http://schemas.openxmlformats.org/drawingml/2006/main">
+            <a:off x="3333750" y="4610100"/>
+            <a:ext cx="266700" cy="171450"/>
+          </a:xfrm>
+          <a:prstGeom xmlns:a="http://schemas.openxmlformats.org/drawingml/2006/main" prst="rightArrow">
+            <a:avLst/>
+          </a:prstGeom>
+          <a:solidFill xmlns:a="http://schemas.openxmlformats.org/drawingml/2006/main">
+            <a:srgbClr val="15845C"/>
+          </a:solidFill>
+          <a:ln xmlns:a="http://schemas.openxmlformats.org/drawingml/2006/main" w="0">
+            <a:noFill/>
+            <a:prstDash val="solid"/>
+          </a:ln>
+        </p:spPr>
+      </p:sp>
+      <p:sp>
+        <p:nvSpPr>
+          <p:cNvPr id="14" name="improvement-arrow-660">
+            <a:extLst xmlns:a="http://schemas.openxmlformats.org/drawingml/2006/main">
+              <a:ext uri="{FF2B5EF4-FFF2-40B4-BE49-F238E27FC236}">
+                <a16:creationId xmlns:a16="http://schemas.microsoft.com/office/drawing/2014/main" id="{BF4B2FD6-2971-43C6-84CD-D82FD7CF36F4}"/>
+              </a:ext>
+            </a:extLst>
+          </p:cNvPr>
+          <p:cNvSpPr>
+            <a:spLocks xmlns:a="http://schemas.openxmlformats.org/drawingml/2006/main" noGrp="1"/>
+          </p:cNvSpPr>
+          <p:nvPr/>
+        </p:nvSpPr>
+        <p:spPr>
+          <a:xfrm xmlns:a="http://schemas.openxmlformats.org/drawingml/2006/main">
+            <a:off x="6286500" y="4610100"/>
+            <a:ext cx="266700" cy="171450"/>
+          </a:xfrm>
+          <a:prstGeom xmlns:a="http://schemas.openxmlformats.org/drawingml/2006/main" prst="rightArrow">
+            <a:avLst/>
+          </a:prstGeom>
+          <a:solidFill xmlns:a="http://schemas.openxmlformats.org/drawingml/2006/main">
+            <a:srgbClr val="15845C"/>
+          </a:solidFill>
+          <a:ln xmlns:a="http://schemas.openxmlformats.org/drawingml/2006/main" w="0">
+            <a:noFill/>
+            <a:prstDash val="solid"/>
+          </a:ln>
+        </p:spPr>
+      </p:sp>
+      <p:sp>
+        <p:nvSpPr>
+          <p:cNvPr id="15" name="manual-release-arrow">
+            <a:extLst xmlns:a="http://schemas.openxmlformats.org/drawingml/2006/main">
+              <a:ext uri="{FF2B5EF4-FFF2-40B4-BE49-F238E27FC236}">
+                <a16:creationId xmlns:a16="http://schemas.microsoft.com/office/drawing/2014/main" id="{B8792B13-AC58-4654-935E-869D55A9634B}"/>
+              </a:ext>
+            </a:extLst>
+          </p:cNvPr>
+          <p:cNvSpPr>
+            <a:spLocks xmlns:a="http://schemas.openxmlformats.org/drawingml/2006/main" noGrp="1"/>
+          </p:cNvSpPr>
+          <p:nvPr/>
+        </p:nvSpPr>
+        <p:spPr>
+          <a:xfrm xmlns:a="http://schemas.openxmlformats.org/drawingml/2006/main">
+            <a:off x="8705850" y="3752850"/>
+            <a:ext cx="190500" cy="228600"/>
+          </a:xfrm>
+          <a:prstGeom xmlns:a="http://schemas.openxmlformats.org/drawingml/2006/main" prst="upArrow">
+            <a:avLst/>
+          </a:prstGeom>
+          <a:solidFill xmlns:a="http://schemas.openxmlformats.org/drawingml/2006/main">
+            <a:srgbClr val="15845C"/>
+          </a:solidFill>
+          <a:ln xmlns:a="http://schemas.openxmlformats.org/drawingml/2006/main" w="0">
+            <a:noFill/>
+            <a:prstDash val="solid"/>
+          </a:ln>
+        </p:spPr>
+      </p:sp>
+      <p:sp>
+        <p:nvSpPr>
+          <p:cNvPr id="16" name="stage-1">
+            <a:extLst xmlns:a="http://schemas.openxmlformats.org/drawingml/2006/main">
+              <a:ext uri="{FF2B5EF4-FFF2-40B4-BE49-F238E27FC236}">
+                <a16:creationId xmlns:a16="http://schemas.microsoft.com/office/drawing/2014/main" id="{2914A299-5FBA-42BA-BB8B-DD795FD47024}"/>
+              </a:ext>
+            </a:extLst>
+          </p:cNvPr>
+          <p:cNvSpPr>
+            <a:spLocks xmlns:a="http://schemas.openxmlformats.org/drawingml/2006/main" noGrp="1"/>
+          </p:cNvSpPr>
+          <p:nvPr/>
+        </p:nvSpPr>
+        <p:spPr>
+          <a:xfrm xmlns:a="http://schemas.openxmlformats.org/drawingml/2006/main">
+            <a:off x="400050" y="1390650"/>
+            <a:ext cx="247650" cy="247650"/>
+          </a:xfrm>
+          <a:prstGeom xmlns:a="http://schemas.openxmlformats.org/drawingml/2006/main" prst="ellipse">
+            <a:avLst/>
+          </a:prstGeom>
+          <a:solidFill xmlns:a="http://schemas.openxmlformats.org/drawingml/2006/main">
+            <a:srgbClr val="17324D"/>
+          </a:solidFill>
+          <a:ln xmlns:a="http://schemas.openxmlformats.org/drawingml/2006/main" w="0">
+            <a:noFill/>
+            <a:prstDash val="solid"/>
+          </a:ln>
+        </p:spPr>
+        <p:txBody>
+          <a:bodyPr xmlns:a="http://schemas.openxmlformats.org/drawingml/2006/main" lIns="0" tIns="0" rIns="0" bIns="0" anchor="ctr">
+            <a:normAutofit fontScale="100000"/>
+          </a:bodyPr>
+          <a:lstStyle xmlns:a="http://schemas.openxmlformats.org/drawingml/2006/main"/>
+          <a:p xmlns:a="http://schemas.openxmlformats.org/drawingml/2006/main">
+            <a:pPr algn="ctr">
+              <a:defRPr sz="975" b="1">
+                <a:solidFill>
+                  <a:srgbClr val="FFFFFF"/>
+                </a:solidFill>
+                <a:latin typeface="Noto Sans JP Thin"/>
+                <a:ea typeface="Noto Sans JP Thin"/>
+                <a:cs typeface="Noto Sans JP Thin"/>
+              </a:defRPr>
+            </a:pPr>
+            <a:r>
+              <a:rPr sz="975" b="1">
+                <a:solidFill>
+                  <a:srgbClr val="FFFFFF"/>
+                </a:solidFill>
+                <a:latin typeface="Noto Sans JP Thin"/>
+                <a:ea typeface="Noto Sans JP Thin"/>
+                <a:cs typeface="Noto Sans JP Thin"/>
+              </a:rPr>
+              <a:t>1</a:t>
+            </a:r>
+          </a:p>
+        </p:txBody>
+      </p:sp>
+      <p:sp>
+        <p:nvSpPr>
+          <p:cNvPr id="17" name="">
+            <a:extLst xmlns:a="http://schemas.openxmlformats.org/drawingml/2006/main">
+              <a:ext uri="{FF2B5EF4-FFF2-40B4-BE49-F238E27FC236}">
+                <a16:creationId xmlns:a16="http://schemas.microsoft.com/office/drawing/2014/main" id="{4ED51CE6-4940-41A7-A0C3-4A7BA1C5E0A0}"/>
+              </a:ext>
+            </a:extLst>
+          </p:cNvPr>
+          <p:cNvSpPr>
+            <a:spLocks xmlns:a="http://schemas.openxmlformats.org/drawingml/2006/main" noGrp="1"/>
+          </p:cNvSpPr>
+          <p:nvPr/>
+        </p:nvSpPr>
+        <p:spPr>
+          <a:xfrm xmlns:a="http://schemas.openxmlformats.org/drawingml/2006/main">
+            <a:off x="723900" y="1409700"/>
+            <a:ext cx="1104900" cy="209550"/>
+          </a:xfrm>
+          <a:prstGeom xmlns:a="http://schemas.openxmlformats.org/drawingml/2006/main" prst="rect">
+            <a:avLst/>
+          </a:prstGeom>
+          <a:noFill xmlns:a="http://schemas.openxmlformats.org/drawingml/2006/main"/>
+          <a:ln xmlns:a="http://schemas.openxmlformats.org/drawingml/2006/main" w="0">
+            <a:noFill/>
+            <a:prstDash val="solid"/>
+          </a:ln>
+        </p:spPr>
+        <p:txBody>
+          <a:bodyPr xmlns:a="http://schemas.openxmlformats.org/drawingml/2006/main" wrap="square" lIns="0" tIns="0" rIns="0" bIns="0" anchor="ctr">
+            <a:normAutofit fontScale="100000"/>
+          </a:bodyPr>
+          <a:lstStyle xmlns:a="http://schemas.openxmlformats.org/drawingml/2006/main"/>
+          <a:p xmlns:a="http://schemas.openxmlformats.org/drawingml/2006/main">
+            <a:pPr algn="l">
+              <a:defRPr sz="975" b="1">
+                <a:solidFill>
+                  <a:srgbClr val="5F6D7A"/>
+                </a:solidFill>
+                <a:latin typeface="Noto Sans JP Thin"/>
+                <a:ea typeface="Noto Sans JP Thin"/>
+                <a:cs typeface="Noto Sans JP Thin"/>
+              </a:defRPr>
+            </a:pPr>
+            <a:r>
+              <a:rPr sz="975" b="1">
+                <a:solidFill>
+                  <a:srgbClr val="5F6D7A"/>
+                </a:solidFill>
+                <a:latin typeface="Noto Sans JP Thin"/>
+                <a:ea typeface="Noto Sans JP Thin"/>
+                <a:cs typeface="Noto Sans JP Thin"/>
+              </a:rPr>
+              <a:t>相談を受ける</a:t>
+            </a:r>
+          </a:p>
+        </p:txBody>
+      </p:sp>
+      <p:sp>
+        <p:nvSpPr>
+          <p:cNvPr id="18" name="stage-2">
+            <a:extLst xmlns:a="http://schemas.openxmlformats.org/drawingml/2006/main">
+              <a:ext uri="{FF2B5EF4-FFF2-40B4-BE49-F238E27FC236}">
+                <a16:creationId xmlns:a16="http://schemas.microsoft.com/office/drawing/2014/main" id="{F66E41EE-23A6-48D0-9B92-B189A61AEA56}"/>
+              </a:ext>
+            </a:extLst>
+          </p:cNvPr>
+          <p:cNvSpPr>
+            <a:spLocks xmlns:a="http://schemas.openxmlformats.org/drawingml/2006/main" noGrp="1"/>
+          </p:cNvSpPr>
+          <p:nvPr/>
+        </p:nvSpPr>
+        <p:spPr>
+          <a:xfrm xmlns:a="http://schemas.openxmlformats.org/drawingml/2006/main">
+            <a:off x="2038350" y="1390650"/>
+            <a:ext cx="247650" cy="247650"/>
+          </a:xfrm>
+          <a:prstGeom xmlns:a="http://schemas.openxmlformats.org/drawingml/2006/main" prst="ellipse">
+            <a:avLst/>
+          </a:prstGeom>
+          <a:solidFill xmlns:a="http://schemas.openxmlformats.org/drawingml/2006/main">
+            <a:srgbClr val="17324D"/>
+          </a:solidFill>
+          <a:ln xmlns:a="http://schemas.openxmlformats.org/drawingml/2006/main" w="0">
+            <a:noFill/>
+            <a:prstDash val="solid"/>
+          </a:ln>
+        </p:spPr>
+        <p:txBody>
+          <a:bodyPr xmlns:a="http://schemas.openxmlformats.org/drawingml/2006/main" lIns="0" tIns="0" rIns="0" bIns="0" anchor="ctr">
+            <a:normAutofit fontScale="100000"/>
+          </a:bodyPr>
+          <a:lstStyle xmlns:a="http://schemas.openxmlformats.org/drawingml/2006/main"/>
+          <a:p xmlns:a="http://schemas.openxmlformats.org/drawingml/2006/main">
+            <a:pPr algn="ctr">
+              <a:defRPr sz="975" b="1">
+                <a:solidFill>
+                  <a:srgbClr val="FFFFFF"/>
+                </a:solidFill>
+                <a:latin typeface="Noto Sans JP Thin"/>
+                <a:ea typeface="Noto Sans JP Thin"/>
+                <a:cs typeface="Noto Sans JP Thin"/>
+              </a:defRPr>
+            </a:pPr>
+            <a:r>
+              <a:rPr sz="975" b="1">
+                <a:solidFill>
+                  <a:srgbClr val="FFFFFF"/>
+                </a:solidFill>
+                <a:latin typeface="Noto Sans JP Thin"/>
+                <a:ea typeface="Noto Sans JP Thin"/>
+                <a:cs typeface="Noto Sans JP Thin"/>
+              </a:rPr>
+              <a:t>2</a:t>
+            </a:r>
+          </a:p>
+        </p:txBody>
+      </p:sp>
+      <p:sp>
+        <p:nvSpPr>
+          <p:cNvPr id="19" name="">
+            <a:extLst xmlns:a="http://schemas.openxmlformats.org/drawingml/2006/main">
+              <a:ext uri="{FF2B5EF4-FFF2-40B4-BE49-F238E27FC236}">
+                <a16:creationId xmlns:a16="http://schemas.microsoft.com/office/drawing/2014/main" id="{409AE0E1-6322-4D91-8420-29A7B4FA750B}"/>
+              </a:ext>
+            </a:extLst>
+          </p:cNvPr>
+          <p:cNvSpPr>
+            <a:spLocks xmlns:a="http://schemas.openxmlformats.org/drawingml/2006/main" noGrp="1"/>
+          </p:cNvSpPr>
+          <p:nvPr/>
+        </p:nvSpPr>
+        <p:spPr>
+          <a:xfrm xmlns:a="http://schemas.openxmlformats.org/drawingml/2006/main">
+            <a:off x="2362200" y="1409700"/>
+            <a:ext cx="1104900" cy="209550"/>
+          </a:xfrm>
+          <a:prstGeom xmlns:a="http://schemas.openxmlformats.org/drawingml/2006/main" prst="rect">
+            <a:avLst/>
+          </a:prstGeom>
+          <a:noFill xmlns:a="http://schemas.openxmlformats.org/drawingml/2006/main"/>
+          <a:ln xmlns:a="http://schemas.openxmlformats.org/drawingml/2006/main" w="0">
+            <a:noFill/>
+            <a:prstDash val="solid"/>
+          </a:ln>
+        </p:spPr>
+        <p:txBody>
+          <a:bodyPr xmlns:a="http://schemas.openxmlformats.org/drawingml/2006/main" wrap="square" lIns="0" tIns="0" rIns="0" bIns="0" anchor="ctr">
+            <a:normAutofit fontScale="100000"/>
+          </a:bodyPr>
+          <a:lstStyle xmlns:a="http://schemas.openxmlformats.org/drawingml/2006/main"/>
+          <a:p xmlns:a="http://schemas.openxmlformats.org/drawingml/2006/main">
+            <a:pPr algn="l">
+              <a:defRPr sz="975" b="1">
+                <a:solidFill>
+                  <a:srgbClr val="5F6D7A"/>
+                </a:solidFill>
+                <a:latin typeface="Noto Sans JP Thin"/>
+                <a:ea typeface="Noto Sans JP Thin"/>
+                <a:cs typeface="Noto Sans JP Thin"/>
+              </a:defRPr>
+            </a:pPr>
+            <a:r>
+              <a:rPr sz="975" b="1">
+                <a:solidFill>
+                  <a:srgbClr val="5F6D7A"/>
+                </a:solidFill>
+                <a:latin typeface="Noto Sans JP Thin"/>
+                <a:ea typeface="Noto Sans JP Thin"/>
+                <a:cs typeface="Noto Sans JP Thin"/>
+              </a:rPr>
+              <a:t>AIが選ぶ</a:t>
+            </a:r>
+          </a:p>
+        </p:txBody>
+      </p:sp>
+      <p:sp>
+        <p:nvSpPr>
+          <p:cNvPr id="20" name="stage-3">
+            <a:extLst xmlns:a="http://schemas.openxmlformats.org/drawingml/2006/main">
+              <a:ext uri="{FF2B5EF4-FFF2-40B4-BE49-F238E27FC236}">
+                <a16:creationId xmlns:a16="http://schemas.microsoft.com/office/drawing/2014/main" id="{34ABFB9F-9094-43E9-A20F-FF5C63323A36}"/>
+              </a:ext>
+            </a:extLst>
+          </p:cNvPr>
+          <p:cNvSpPr>
+            <a:spLocks xmlns:a="http://schemas.openxmlformats.org/drawingml/2006/main" noGrp="1"/>
+          </p:cNvSpPr>
+          <p:nvPr/>
+        </p:nvSpPr>
+        <p:spPr>
+          <a:xfrm xmlns:a="http://schemas.openxmlformats.org/drawingml/2006/main">
+            <a:off x="3943350" y="1390650"/>
+            <a:ext cx="247650" cy="247650"/>
+          </a:xfrm>
+          <a:prstGeom xmlns:a="http://schemas.openxmlformats.org/drawingml/2006/main" prst="ellipse">
+            <a:avLst/>
+          </a:prstGeom>
+          <a:solidFill xmlns:a="http://schemas.openxmlformats.org/drawingml/2006/main">
+            <a:srgbClr val="17324D"/>
+          </a:solidFill>
+          <a:ln xmlns:a="http://schemas.openxmlformats.org/drawingml/2006/main" w="0">
+            <a:noFill/>
+            <a:prstDash val="solid"/>
+          </a:ln>
+        </p:spPr>
+        <p:txBody>
+          <a:bodyPr xmlns:a="http://schemas.openxmlformats.org/drawingml/2006/main" lIns="0" tIns="0" rIns="0" bIns="0" anchor="ctr">
+            <a:normAutofit fontScale="100000"/>
+          </a:bodyPr>
+          <a:lstStyle xmlns:a="http://schemas.openxmlformats.org/drawingml/2006/main"/>
+          <a:p xmlns:a="http://schemas.openxmlformats.org/drawingml/2006/main">
+            <a:pPr algn="ctr">
+              <a:defRPr sz="975" b="1">
+                <a:solidFill>
+                  <a:srgbClr val="FFFFFF"/>
+                </a:solidFill>
+                <a:latin typeface="Noto Sans JP Thin"/>
+                <a:ea typeface="Noto Sans JP Thin"/>
+                <a:cs typeface="Noto Sans JP Thin"/>
+              </a:defRPr>
+            </a:pPr>
+            <a:r>
+              <a:rPr sz="975" b="1">
+                <a:solidFill>
+                  <a:srgbClr val="FFFFFF"/>
+                </a:solidFill>
+                <a:latin typeface="Noto Sans JP Thin"/>
+                <a:ea typeface="Noto Sans JP Thin"/>
+                <a:cs typeface="Noto Sans JP Thin"/>
+              </a:rPr>
+              <a:t>3</a:t>
+            </a:r>
+          </a:p>
+        </p:txBody>
+      </p:sp>
+      <p:sp>
+        <p:nvSpPr>
+          <p:cNvPr id="21" name="">
+            <a:extLst xmlns:a="http://schemas.openxmlformats.org/drawingml/2006/main">
+              <a:ext uri="{FF2B5EF4-FFF2-40B4-BE49-F238E27FC236}">
+                <a16:creationId xmlns:a16="http://schemas.microsoft.com/office/drawing/2014/main" id="{7D677BE7-8642-44CB-B3D5-980C59DD51C7}"/>
+              </a:ext>
+            </a:extLst>
+          </p:cNvPr>
+          <p:cNvSpPr>
+            <a:spLocks xmlns:a="http://schemas.openxmlformats.org/drawingml/2006/main" noGrp="1"/>
+          </p:cNvSpPr>
+          <p:nvPr/>
+        </p:nvSpPr>
+        <p:spPr>
+          <a:xfrm xmlns:a="http://schemas.openxmlformats.org/drawingml/2006/main">
+            <a:off x="4267200" y="1409700"/>
+            <a:ext cx="1104900" cy="209550"/>
+          </a:xfrm>
+          <a:prstGeom xmlns:a="http://schemas.openxmlformats.org/drawingml/2006/main" prst="rect">
+            <a:avLst/>
+          </a:prstGeom>
+          <a:noFill xmlns:a="http://schemas.openxmlformats.org/drawingml/2006/main"/>
+          <a:ln xmlns:a="http://schemas.openxmlformats.org/drawingml/2006/main" w="0">
+            <a:noFill/>
+            <a:prstDash val="solid"/>
+          </a:ln>
+        </p:spPr>
+        <p:txBody>
+          <a:bodyPr xmlns:a="http://schemas.openxmlformats.org/drawingml/2006/main" wrap="square" lIns="0" tIns="0" rIns="0" bIns="0" anchor="ctr">
+            <a:normAutofit fontScale="100000"/>
+          </a:bodyPr>
+          <a:lstStyle xmlns:a="http://schemas.openxmlformats.org/drawingml/2006/main"/>
+          <a:p xmlns:a="http://schemas.openxmlformats.org/drawingml/2006/main">
+            <a:pPr algn="l">
+              <a:defRPr sz="975" b="1">
+                <a:solidFill>
+                  <a:srgbClr val="5F6D7A"/>
+                </a:solidFill>
+                <a:latin typeface="Noto Sans JP Thin"/>
+                <a:ea typeface="Noto Sans JP Thin"/>
+                <a:cs typeface="Noto Sans JP Thin"/>
+              </a:defRPr>
+            </a:pPr>
+            <a:r>
+              <a:rPr sz="975" b="1">
+                <a:solidFill>
+                  <a:srgbClr val="5F6D7A"/>
+                </a:solidFill>
+                <a:latin typeface="Noto Sans JP Thin"/>
+                <a:ea typeface="Noto Sans JP Thin"/>
+                <a:cs typeface="Noto Sans JP Thin"/>
+              </a:rPr>
+              <a:t>コードが再現</a:t>
+            </a:r>
+          </a:p>
+        </p:txBody>
+      </p:sp>
+      <p:sp>
+        <p:nvSpPr>
+          <p:cNvPr id="22" name="stage-4">
+            <a:extLst xmlns:a="http://schemas.openxmlformats.org/drawingml/2006/main">
+              <a:ext uri="{FF2B5EF4-FFF2-40B4-BE49-F238E27FC236}">
+                <a16:creationId xmlns:a16="http://schemas.microsoft.com/office/drawing/2014/main" id="{4363F6B2-CB74-4A2D-82BC-CA655D4EF9CC}"/>
+              </a:ext>
+            </a:extLst>
+          </p:cNvPr>
+          <p:cNvSpPr>
+            <a:spLocks xmlns:a="http://schemas.openxmlformats.org/drawingml/2006/main" noGrp="1"/>
+          </p:cNvSpPr>
+          <p:nvPr/>
+        </p:nvSpPr>
+        <p:spPr>
+          <a:xfrm xmlns:a="http://schemas.openxmlformats.org/drawingml/2006/main">
+            <a:off x="6153150" y="1390650"/>
+            <a:ext cx="247650" cy="247650"/>
+          </a:xfrm>
+          <a:prstGeom xmlns:a="http://schemas.openxmlformats.org/drawingml/2006/main" prst="ellipse">
+            <a:avLst/>
+          </a:prstGeom>
+          <a:solidFill xmlns:a="http://schemas.openxmlformats.org/drawingml/2006/main">
+            <a:srgbClr val="17324D"/>
+          </a:solidFill>
+          <a:ln xmlns:a="http://schemas.openxmlformats.org/drawingml/2006/main" w="0">
+            <a:noFill/>
+            <a:prstDash val="solid"/>
+          </a:ln>
+        </p:spPr>
+        <p:txBody>
+          <a:bodyPr xmlns:a="http://schemas.openxmlformats.org/drawingml/2006/main" lIns="0" tIns="0" rIns="0" bIns="0" anchor="ctr">
+            <a:normAutofit fontScale="100000"/>
+          </a:bodyPr>
+          <a:lstStyle xmlns:a="http://schemas.openxmlformats.org/drawingml/2006/main"/>
+          <a:p xmlns:a="http://schemas.openxmlformats.org/drawingml/2006/main">
+            <a:pPr algn="ctr">
+              <a:defRPr sz="975" b="1">
+                <a:solidFill>
+                  <a:srgbClr val="FFFFFF"/>
+                </a:solidFill>
+                <a:latin typeface="Noto Sans JP Thin"/>
+                <a:ea typeface="Noto Sans JP Thin"/>
+                <a:cs typeface="Noto Sans JP Thin"/>
+              </a:defRPr>
+            </a:pPr>
+            <a:r>
+              <a:rPr sz="975" b="1">
+                <a:solidFill>
+                  <a:srgbClr val="FFFFFF"/>
+                </a:solidFill>
+                <a:latin typeface="Noto Sans JP Thin"/>
+                <a:ea typeface="Noto Sans JP Thin"/>
+                <a:cs typeface="Noto Sans JP Thin"/>
+              </a:rPr>
+              <a:t>4</a:t>
+            </a:r>
+          </a:p>
+        </p:txBody>
+      </p:sp>
+      <p:sp>
+        <p:nvSpPr>
+          <p:cNvPr id="23" name="">
+            <a:extLst xmlns:a="http://schemas.openxmlformats.org/drawingml/2006/main">
+              <a:ext uri="{FF2B5EF4-FFF2-40B4-BE49-F238E27FC236}">
+                <a16:creationId xmlns:a16="http://schemas.microsoft.com/office/drawing/2014/main" id="{72AAA3FD-852B-42CF-9E95-CD07687370BE}"/>
+              </a:ext>
+            </a:extLst>
+          </p:cNvPr>
+          <p:cNvSpPr>
+            <a:spLocks xmlns:a="http://schemas.openxmlformats.org/drawingml/2006/main" noGrp="1"/>
+          </p:cNvSpPr>
+          <p:nvPr/>
+        </p:nvSpPr>
+        <p:spPr>
+          <a:xfrm xmlns:a="http://schemas.openxmlformats.org/drawingml/2006/main">
+            <a:off x="6477000" y="1409700"/>
+            <a:ext cx="1104900" cy="209550"/>
+          </a:xfrm>
+          <a:prstGeom xmlns:a="http://schemas.openxmlformats.org/drawingml/2006/main" prst="rect">
+            <a:avLst/>
+          </a:prstGeom>
+          <a:noFill xmlns:a="http://schemas.openxmlformats.org/drawingml/2006/main"/>
+          <a:ln xmlns:a="http://schemas.openxmlformats.org/drawingml/2006/main" w="0">
+            <a:noFill/>
+            <a:prstDash val="solid"/>
+          </a:ln>
+        </p:spPr>
+        <p:txBody>
+          <a:bodyPr xmlns:a="http://schemas.openxmlformats.org/drawingml/2006/main" wrap="square" lIns="0" tIns="0" rIns="0" bIns="0" anchor="ctr">
+            <a:normAutofit fontScale="100000"/>
+          </a:bodyPr>
+          <a:lstStyle xmlns:a="http://schemas.openxmlformats.org/drawingml/2006/main"/>
+          <a:p xmlns:a="http://schemas.openxmlformats.org/drawingml/2006/main">
+            <a:pPr algn="l">
+              <a:defRPr sz="975" b="1">
+                <a:solidFill>
+                  <a:srgbClr val="5F6D7A"/>
+                </a:solidFill>
+                <a:latin typeface="Noto Sans JP Thin"/>
+                <a:ea typeface="Noto Sans JP Thin"/>
+                <a:cs typeface="Noto Sans JP Thin"/>
+              </a:defRPr>
+            </a:pPr>
+            <a:r>
+              <a:rPr sz="975" b="1">
+                <a:solidFill>
+                  <a:srgbClr val="5F6D7A"/>
+                </a:solidFill>
+                <a:latin typeface="Noto Sans JP Thin"/>
+                <a:ea typeface="Noto Sans JP Thin"/>
+                <a:cs typeface="Noto Sans JP Thin"/>
+              </a:rPr>
+              <a:t>人が判断</a:t>
+            </a:r>
+          </a:p>
+        </p:txBody>
+      </p:sp>
+      <p:sp>
+        <p:nvSpPr>
+          <p:cNvPr id="24" name="stage-5">
+            <a:extLst xmlns:a="http://schemas.openxmlformats.org/drawingml/2006/main">
+              <a:ext uri="{FF2B5EF4-FFF2-40B4-BE49-F238E27FC236}">
+                <a16:creationId xmlns:a16="http://schemas.microsoft.com/office/drawing/2014/main" id="{02640AEC-8454-4F69-B2D5-31D344E05F8E}"/>
+              </a:ext>
+            </a:extLst>
+          </p:cNvPr>
+          <p:cNvSpPr>
+            <a:spLocks xmlns:a="http://schemas.openxmlformats.org/drawingml/2006/main" noGrp="1"/>
+          </p:cNvSpPr>
+          <p:nvPr/>
+        </p:nvSpPr>
+        <p:spPr>
+          <a:xfrm xmlns:a="http://schemas.openxmlformats.org/drawingml/2006/main">
+            <a:off x="8134350" y="1390650"/>
+            <a:ext cx="247650" cy="247650"/>
+          </a:xfrm>
+          <a:prstGeom xmlns:a="http://schemas.openxmlformats.org/drawingml/2006/main" prst="ellipse">
+            <a:avLst/>
+          </a:prstGeom>
+          <a:solidFill xmlns:a="http://schemas.openxmlformats.org/drawingml/2006/main">
+            <a:srgbClr val="17324D"/>
+          </a:solidFill>
+          <a:ln xmlns:a="http://schemas.openxmlformats.org/drawingml/2006/main" w="0">
+            <a:noFill/>
+            <a:prstDash val="solid"/>
+          </a:ln>
+        </p:spPr>
+        <p:txBody>
+          <a:bodyPr xmlns:a="http://schemas.openxmlformats.org/drawingml/2006/main" lIns="0" tIns="0" rIns="0" bIns="0" anchor="ctr">
+            <a:normAutofit fontScale="100000"/>
+          </a:bodyPr>
+          <a:lstStyle xmlns:a="http://schemas.openxmlformats.org/drawingml/2006/main"/>
+          <a:p xmlns:a="http://schemas.openxmlformats.org/drawingml/2006/main">
+            <a:pPr algn="ctr">
+              <a:defRPr sz="975" b="1">
+                <a:solidFill>
+                  <a:srgbClr val="FFFFFF"/>
+                </a:solidFill>
+                <a:latin typeface="Noto Sans JP Thin"/>
+                <a:ea typeface="Noto Sans JP Thin"/>
+                <a:cs typeface="Noto Sans JP Thin"/>
+              </a:defRPr>
+            </a:pPr>
+            <a:r>
+              <a:rPr sz="975" b="1">
+                <a:solidFill>
+                  <a:srgbClr val="FFFFFF"/>
+                </a:solidFill>
+                <a:latin typeface="Noto Sans JP Thin"/>
+                <a:ea typeface="Noto Sans JP Thin"/>
+                <a:cs typeface="Noto Sans JP Thin"/>
+              </a:rPr>
+              <a:t>5</a:t>
+            </a:r>
+          </a:p>
+        </p:txBody>
+      </p:sp>
+      <p:sp>
+        <p:nvSpPr>
+          <p:cNvPr id="25" name="">
+            <a:extLst xmlns:a="http://schemas.openxmlformats.org/drawingml/2006/main">
+              <a:ext uri="{FF2B5EF4-FFF2-40B4-BE49-F238E27FC236}">
+                <a16:creationId xmlns:a16="http://schemas.microsoft.com/office/drawing/2014/main" id="{F3DB53FD-A2FE-4B78-8411-88D22E8A9F57}"/>
+              </a:ext>
+            </a:extLst>
+          </p:cNvPr>
+          <p:cNvSpPr>
+            <a:spLocks xmlns:a="http://schemas.openxmlformats.org/drawingml/2006/main" noGrp="1"/>
+          </p:cNvSpPr>
+          <p:nvPr/>
+        </p:nvSpPr>
+        <p:spPr>
+          <a:xfrm xmlns:a="http://schemas.openxmlformats.org/drawingml/2006/main">
+            <a:off x="8458200" y="1409700"/>
+            <a:ext cx="1104900" cy="209550"/>
+          </a:xfrm>
+          <a:prstGeom xmlns:a="http://schemas.openxmlformats.org/drawingml/2006/main" prst="rect">
+            <a:avLst/>
+          </a:prstGeom>
+          <a:noFill xmlns:a="http://schemas.openxmlformats.org/drawingml/2006/main"/>
+          <a:ln xmlns:a="http://schemas.openxmlformats.org/drawingml/2006/main" w="0">
+            <a:noFill/>
+            <a:prstDash val="solid"/>
+          </a:ln>
+        </p:spPr>
+        <p:txBody>
+          <a:bodyPr xmlns:a="http://schemas.openxmlformats.org/drawingml/2006/main" wrap="square" lIns="0" tIns="0" rIns="0" bIns="0" anchor="ctr">
+            <a:normAutofit fontScale="100000"/>
+          </a:bodyPr>
+          <a:lstStyle xmlns:a="http://schemas.openxmlformats.org/drawingml/2006/main"/>
+          <a:p xmlns:a="http://schemas.openxmlformats.org/drawingml/2006/main">
+            <a:pPr algn="l">
+              <a:defRPr sz="975" b="1">
+                <a:solidFill>
+                  <a:srgbClr val="5F6D7A"/>
+                </a:solidFill>
+                <a:latin typeface="Noto Sans JP Thin"/>
+                <a:ea typeface="Noto Sans JP Thin"/>
+                <a:cs typeface="Noto Sans JP Thin"/>
+              </a:defRPr>
+            </a:pPr>
+            <a:r>
+              <a:rPr sz="975" b="1">
+                <a:solidFill>
+                  <a:srgbClr val="5F6D7A"/>
+                </a:solidFill>
+                <a:latin typeface="Noto Sans JP Thin"/>
+                <a:ea typeface="Noto Sans JP Thin"/>
+                <a:cs typeface="Noto Sans JP Thin"/>
+              </a:rPr>
+              <a:t>成果を出す</a:t>
+            </a:r>
+          </a:p>
+        </p:txBody>
+      </p:sp>
+      <p:sp>
+        <p:nvSpPr>
+          <p:cNvPr id="26" name="">
+            <a:extLst xmlns:a="http://schemas.openxmlformats.org/drawingml/2006/main">
+              <a:ext uri="{FF2B5EF4-FFF2-40B4-BE49-F238E27FC236}">
+                <a16:creationId xmlns:a16="http://schemas.microsoft.com/office/drawing/2014/main" id="{225AC635-7215-4AB8-BBA3-A7FD095EC6BC}"/>
+              </a:ext>
+            </a:extLst>
+          </p:cNvPr>
+          <p:cNvSpPr>
+            <a:spLocks xmlns:a="http://schemas.openxmlformats.org/drawingml/2006/main" noGrp="1"/>
+          </p:cNvSpPr>
+          <p:nvPr/>
+        </p:nvSpPr>
+        <p:spPr>
+          <a:xfrm xmlns:a="http://schemas.openxmlformats.org/drawingml/2006/main">
+            <a:off x="400050" y="1695450"/>
+            <a:ext cx="1257300" cy="990600"/>
           </a:xfrm>
           <a:prstGeom xmlns:a="http://schemas.openxmlformats.org/drawingml/2006/main" prst="roundRect">
             <a:avLst>
-              <a:gd name="adj" fmla="val 13793"/>
+              <a:gd name="adj" fmla="val 15385"/>
             </a:avLst>
           </a:prstGeom>
           <a:solidFill xmlns:a="http://schemas.openxmlformats.org/drawingml/2006/main">
@@ -4397,14 +5266,20 @@
             <a:prstDash val="solid"/>
           </a:ln>
         </p:spPr>
-        <p:txBody>
-          <a:bodyPr xmlns:a="http://schemas.openxmlformats.org/drawingml/2006/main" wrap="square" lIns="76200" tIns="76200" rIns="76200" bIns="76200" anchor="ctr">
-            <a:normAutofit fontScale="96487"/>
+        <p:style>
+          <a:lnRef xmlns:a="http://schemas.openxmlformats.org/drawingml/2006/main" idx="0"/>
+          <a:fillRef xmlns:a="http://schemas.openxmlformats.org/drawingml/2006/main" idx="0"/>
+          <a:effectRef xmlns:a="http://schemas.openxmlformats.org/drawingml/2006/main" idx="4"/>
+          <a:fontRef xmlns:a="http://schemas.openxmlformats.org/drawingml/2006/main" idx="major"/>
+        </p:style>
+        <p:txBody>
+          <a:bodyPr xmlns:a="http://schemas.openxmlformats.org/drawingml/2006/main" wrap="square" lIns="66675" tIns="76200" rIns="66675" bIns="76200" anchor="ctr">
+            <a:normAutofit fontScale="100000"/>
           </a:bodyPr>
           <a:lstStyle xmlns:a="http://schemas.openxmlformats.org/drawingml/2006/main"/>
           <a:p xmlns:a="http://schemas.openxmlformats.org/drawingml/2006/main">
             <a:pPr algn="ctr">
-              <a:defRPr sz="1200" b="1">
+              <a:defRPr sz="1125" b="1">
                 <a:solidFill>
                   <a:srgbClr val="C25B24"/>
                 </a:solidFill>
@@ -4414,7 +5289,7 @@
               </a:defRPr>
             </a:pPr>
             <a:r>
-              <a:rPr sz="1200" b="1">
+              <a:rPr sz="1125" b="1">
                 <a:solidFill>
                   <a:srgbClr val="C25B24"/>
                 </a:solidFill>
@@ -4422,12 +5297,12 @@
                 <a:ea typeface="Noto Sans JP Thin"/>
                 <a:cs typeface="Noto Sans JP Thin"/>
               </a:rPr>
-              <a:t>税理士</a:t>
+              <a:t>散文相談・相続人情報</a:t>
             </a:r>
           </a:p>
           <a:p xmlns:a="http://schemas.openxmlformats.org/drawingml/2006/main">
             <a:pPr algn="ctr">
-              <a:defRPr sz="1200" b="1">
+              <a:defRPr sz="1125" b="1">
                 <a:solidFill>
                   <a:srgbClr val="C25B24"/>
                 </a:solidFill>
@@ -4437,7 +5312,7 @@
               </a:defRPr>
             </a:pPr>
             <a:r>
-              <a:rPr sz="1200" b="1">
+              <a:rPr sz="1125" b="1">
                 <a:solidFill>
                   <a:srgbClr val="C25B24"/>
                 </a:solidFill>
@@ -4445,171 +5320,33 @@
                 <a:ea typeface="Noto Sans JP Thin"/>
                 <a:cs typeface="Noto Sans JP Thin"/>
               </a:rPr>
-              <a:t>散文相談・カード</a:t>
-            </a:r>
-          </a:p>
-          <a:p xmlns:a="http://schemas.openxmlformats.org/drawingml/2006/main">
-            <a:pPr algn="ctr">
-              <a:defRPr sz="1200" b="1">
-                <a:solidFill>
-                  <a:srgbClr val="C25B24"/>
-                </a:solidFill>
-                <a:latin typeface="Noto Sans JP Thin"/>
-                <a:ea typeface="Noto Sans JP Thin"/>
-                <a:cs typeface="Noto Sans JP Thin"/>
-              </a:defRPr>
-            </a:pPr>
-            <a:r>
-              <a:rPr sz="1200" b="1">
-                <a:solidFill>
-                  <a:srgbClr val="C25B24"/>
-                </a:solidFill>
-                <a:latin typeface="Noto Sans JP Thin"/>
-                <a:ea typeface="Noto Sans JP Thin"/>
-                <a:cs typeface="Noto Sans JP Thin"/>
-              </a:rPr>
-              <a:t>追加回答・承認</a:t>
-            </a:r>
-          </a:p>
-        </p:txBody>
-      </p:sp>
-      <p:sp>
-        <p:nvSpPr>
-          <p:cNvPr id="8" name="">
-            <a:extLst xmlns:a="http://schemas.openxmlformats.org/drawingml/2006/main">
-              <a:ext uri="{FF2B5EF4-FFF2-40B4-BE49-F238E27FC236}">
-                <a16:creationId xmlns:a16="http://schemas.microsoft.com/office/drawing/2014/main" id="{917F7ED2-2ABC-4E60-A3F3-9366CCE06995}"/>
-              </a:ext>
-            </a:extLst>
-          </p:cNvPr>
-          <p:cNvSpPr>
-            <a:spLocks xmlns:a="http://schemas.openxmlformats.org/drawingml/2006/main" noGrp="1"/>
-          </p:cNvSpPr>
-          <p:nvPr/>
-        </p:nvSpPr>
-        <p:spPr>
-          <a:xfrm xmlns:a="http://schemas.openxmlformats.org/drawingml/2006/main">
-            <a:off x="1981200" y="1581150"/>
-            <a:ext cx="1676400" cy="1314450"/>
+              <a:t>追加回答を入力</a:t>
+            </a:r>
+          </a:p>
+        </p:txBody>
+      </p:sp>
+      <p:sp>
+        <p:nvSpPr>
+          <p:cNvPr id="27" name="">
+            <a:extLst xmlns:a="http://schemas.openxmlformats.org/drawingml/2006/main">
+              <a:ext uri="{FF2B5EF4-FFF2-40B4-BE49-F238E27FC236}">
+                <a16:creationId xmlns:a16="http://schemas.microsoft.com/office/drawing/2014/main" id="{8AE1921F-9874-48FE-8E64-8CD28942950B}"/>
+              </a:ext>
+            </a:extLst>
+          </p:cNvPr>
+          <p:cNvSpPr>
+            <a:spLocks xmlns:a="http://schemas.openxmlformats.org/drawingml/2006/main" noGrp="1"/>
+          </p:cNvSpPr>
+          <p:nvPr/>
+        </p:nvSpPr>
+        <p:spPr>
+          <a:xfrm xmlns:a="http://schemas.openxmlformats.org/drawingml/2006/main">
+            <a:off x="2038350" y="1695450"/>
+            <a:ext cx="1504950" cy="990600"/>
           </a:xfrm>
           <a:prstGeom xmlns:a="http://schemas.openxmlformats.org/drawingml/2006/main" prst="roundRect">
             <a:avLst>
-              <a:gd name="adj" fmla="val 11594"/>
-            </a:avLst>
-          </a:prstGeom>
-          <a:solidFill xmlns:a="http://schemas.openxmlformats.org/drawingml/2006/main">
-            <a:srgbClr val="E8F0FF"/>
-          </a:solidFill>
-          <a:ln xmlns:a="http://schemas.openxmlformats.org/drawingml/2006/main" w="14288">
-            <a:solidFill>
-              <a:srgbClr val="2F6FED"/>
-            </a:solidFill>
-            <a:prstDash val="solid"/>
-          </a:ln>
-        </p:spPr>
-        <p:txBody>
-          <a:bodyPr xmlns:a="http://schemas.openxmlformats.org/drawingml/2006/main" wrap="square" lIns="76200" tIns="76200" rIns="76200" bIns="76200" anchor="ctr">
-            <a:normAutofit fontScale="100000"/>
-          </a:bodyPr>
-          <a:lstStyle xmlns:a="http://schemas.openxmlformats.org/drawingml/2006/main"/>
-          <a:p xmlns:a="http://schemas.openxmlformats.org/drawingml/2006/main">
-            <a:pPr algn="ctr">
-              <a:defRPr sz="1275" b="1">
-                <a:solidFill>
-                  <a:srgbClr val="17324D"/>
-                </a:solidFill>
-                <a:latin typeface="Noto Sans JP Thin"/>
-                <a:ea typeface="Noto Sans JP Thin"/>
-                <a:cs typeface="Noto Sans JP Thin"/>
-              </a:defRPr>
-            </a:pPr>
-            <a:r>
-              <a:rPr sz="1275" b="1">
-                <a:solidFill>
-                  <a:srgbClr val="17324D"/>
-                </a:solidFill>
-                <a:latin typeface="Noto Sans JP Thin"/>
-                <a:ea typeface="Noto Sans JP Thin"/>
-                <a:cs typeface="Noto Sans JP Thin"/>
-              </a:rPr>
-              <a:t>FastAPI / Agent Router</a:t>
-            </a:r>
-          </a:p>
-          <a:p xmlns:a="http://schemas.openxmlformats.org/drawingml/2006/main">
-            <a:r>
-              <a:t/>
-            </a:r>
-          </a:p>
-          <a:p xmlns:a="http://schemas.openxmlformats.org/drawingml/2006/main">
-            <a:pPr algn="ctr">
-              <a:defRPr sz="1275" b="1">
-                <a:solidFill>
-                  <a:srgbClr val="17324D"/>
-                </a:solidFill>
-                <a:latin typeface="Noto Sans JP Thin"/>
-                <a:ea typeface="Noto Sans JP Thin"/>
-                <a:cs typeface="Noto Sans JP Thin"/>
-              </a:defRPr>
-            </a:pPr>
-            <a:r>
-              <a:rPr sz="1275" b="1">
-                <a:solidFill>
-                  <a:srgbClr val="17324D"/>
-                </a:solidFill>
-                <a:latin typeface="Noto Sans JP Thin"/>
-                <a:ea typeface="Noto Sans JP Thin"/>
-                <a:cs typeface="Noto Sans JP Thin"/>
-              </a:rPr>
-              <a:t>進む／聞く</a:t>
-            </a:r>
-          </a:p>
-          <a:p xmlns:a="http://schemas.openxmlformats.org/drawingml/2006/main">
-            <a:pPr algn="ctr">
-              <a:defRPr sz="1275" b="1">
-                <a:solidFill>
-                  <a:srgbClr val="17324D"/>
-                </a:solidFill>
-                <a:latin typeface="Noto Sans JP Thin"/>
-                <a:ea typeface="Noto Sans JP Thin"/>
-                <a:cs typeface="Noto Sans JP Thin"/>
-              </a:defRPr>
-            </a:pPr>
-            <a:r>
-              <a:rPr sz="1275" b="1">
-                <a:solidFill>
-                  <a:srgbClr val="17324D"/>
-                </a:solidFill>
-                <a:latin typeface="Noto Sans JP Thin"/>
-                <a:ea typeface="Noto Sans JP Thin"/>
-                <a:cs typeface="Noto Sans JP Thin"/>
-              </a:rPr>
-              <a:t>構造化事実を優先</a:t>
-            </a:r>
-          </a:p>
-        </p:txBody>
-      </p:sp>
-      <p:sp>
-        <p:nvSpPr>
-          <p:cNvPr id="9" name="">
-            <a:extLst xmlns:a="http://schemas.openxmlformats.org/drawingml/2006/main">
-              <a:ext uri="{FF2B5EF4-FFF2-40B4-BE49-F238E27FC236}">
-                <a16:creationId xmlns:a16="http://schemas.microsoft.com/office/drawing/2014/main" id="{58C78295-0236-406E-9116-F8C7B379DFDE}"/>
-              </a:ext>
-            </a:extLst>
-          </p:cNvPr>
-          <p:cNvSpPr>
-            <a:spLocks xmlns:a="http://schemas.openxmlformats.org/drawingml/2006/main" noGrp="1"/>
-          </p:cNvSpPr>
-          <p:nvPr/>
-        </p:nvSpPr>
-        <p:spPr>
-          <a:xfrm xmlns:a="http://schemas.openxmlformats.org/drawingml/2006/main">
-            <a:off x="1981200" y="1104900"/>
-            <a:ext cx="1676400" cy="438150"/>
-          </a:xfrm>
-          <a:prstGeom xmlns:a="http://schemas.openxmlformats.org/drawingml/2006/main" prst="roundRect">
-            <a:avLst>
-              <a:gd name="adj" fmla="val 34783"/>
+              <a:gd name="adj" fmla="val 15385"/>
             </a:avLst>
           </a:prstGeom>
           <a:solidFill xmlns:a="http://schemas.openxmlformats.org/drawingml/2006/main">
@@ -4622,14 +5359,20 @@
             <a:prstDash val="solid"/>
           </a:ln>
         </p:spPr>
-        <p:txBody>
-          <a:bodyPr xmlns:a="http://schemas.openxmlformats.org/drawingml/2006/main" wrap="square" lIns="66675" tIns="28575" rIns="66675" bIns="28575" anchor="ctr">
-            <a:normAutofit fontScale="65443"/>
+        <p:style>
+          <a:lnRef xmlns:a="http://schemas.openxmlformats.org/drawingml/2006/main" idx="0"/>
+          <a:fillRef xmlns:a="http://schemas.openxmlformats.org/drawingml/2006/main" idx="0"/>
+          <a:effectRef xmlns:a="http://schemas.openxmlformats.org/drawingml/2006/main" idx="4"/>
+          <a:fontRef xmlns:a="http://schemas.openxmlformats.org/drawingml/2006/main" idx="major"/>
+        </p:style>
+        <p:txBody>
+          <a:bodyPr xmlns:a="http://schemas.openxmlformats.org/drawingml/2006/main" wrap="square" lIns="57150" tIns="66675" rIns="57150" bIns="66675" anchor="ctr">
+            <a:normAutofit fontScale="100000"/>
           </a:bodyPr>
           <a:lstStyle xmlns:a="http://schemas.openxmlformats.org/drawingml/2006/main"/>
           <a:p xmlns:a="http://schemas.openxmlformats.org/drawingml/2006/main">
             <a:pPr algn="ctr">
-              <a:defRPr sz="975" b="1">
+              <a:defRPr sz="1050" b="1">
                 <a:solidFill>
                   <a:srgbClr val="7356C8"/>
                 </a:solidFill>
@@ -4639,7 +5382,7 @@
               </a:defRPr>
             </a:pPr>
             <a:r>
-              <a:rPr sz="975" b="1">
+              <a:rPr sz="1050" b="1">
                 <a:solidFill>
                   <a:srgbClr val="7356C8"/>
                 </a:solidFill>
@@ -4652,7 +5395,7 @@
           </a:p>
           <a:p xmlns:a="http://schemas.openxmlformats.org/drawingml/2006/main">
             <a:pPr algn="ctr">
-              <a:defRPr sz="975" b="1">
+              <a:defRPr sz="1050" b="1">
                 <a:solidFill>
                   <a:srgbClr val="7356C8"/>
                 </a:solidFill>
@@ -4662,7 +5405,7 @@
               </a:defRPr>
             </a:pPr>
             <a:r>
-              <a:rPr sz="975" b="1">
+              <a:rPr sz="1050" b="1">
                 <a:solidFill>
                   <a:srgbClr val="7356C8"/>
                 </a:solidFill>
@@ -4670,12 +5413,12 @@
                 <a:ea typeface="Noto Sans JP Thin"/>
                 <a:cs typeface="Noto Sans JP Thin"/>
               </a:rPr>
-              <a:t>Function Calling</a:t>
+              <a:t>進むか聞くかを選ぶ</a:t>
             </a:r>
           </a:p>
           <a:p xmlns:a="http://schemas.openxmlformats.org/drawingml/2006/main">
             <a:pPr algn="ctr">
-              <a:defRPr sz="975" b="1">
+              <a:defRPr sz="1050" b="1">
                 <a:solidFill>
                   <a:srgbClr val="7356C8"/>
                 </a:solidFill>
@@ -4685,7 +5428,7 @@
               </a:defRPr>
             </a:pPr>
             <a:r>
-              <a:rPr sz="975" b="1">
+              <a:rPr sz="1050" b="1">
                 <a:solidFill>
                   <a:srgbClr val="7356C8"/>
                 </a:solidFill>
@@ -4693,33 +5436,358 @@
                 <a:ea typeface="Noto Sans JP Thin"/>
                 <a:cs typeface="Noto Sans JP Thin"/>
               </a:rPr>
-              <a:t>税務結論は生成しない</a:t>
-            </a:r>
-          </a:p>
-        </p:txBody>
-      </p:sp>
-      <p:sp>
-        <p:nvSpPr>
-          <p:cNvPr id="10" name="">
-            <a:extLst xmlns:a="http://schemas.openxmlformats.org/drawingml/2006/main">
-              <a:ext uri="{FF2B5EF4-FFF2-40B4-BE49-F238E27FC236}">
-                <a16:creationId xmlns:a16="http://schemas.microsoft.com/office/drawing/2014/main" id="{5E6FF1A8-76E1-4C57-91C1-F6D816672486}"/>
-              </a:ext>
-            </a:extLst>
-          </p:cNvPr>
-          <p:cNvSpPr>
-            <a:spLocks xmlns:a="http://schemas.openxmlformats.org/drawingml/2006/main" noGrp="1"/>
-          </p:cNvSpPr>
-          <p:nvPr/>
-        </p:nvSpPr>
-        <p:spPr>
-          <a:xfrm xmlns:a="http://schemas.openxmlformats.org/drawingml/2006/main">
-            <a:off x="1981200" y="3009900"/>
-            <a:ext cx="1676400" cy="685800"/>
+              <a:t>税務結論は作らない</a:t>
+            </a:r>
+          </a:p>
+        </p:txBody>
+      </p:sp>
+      <p:sp>
+        <p:nvSpPr>
+          <p:cNvPr id="28" name="">
+            <a:extLst xmlns:a="http://schemas.openxmlformats.org/drawingml/2006/main">
+              <a:ext uri="{FF2B5EF4-FFF2-40B4-BE49-F238E27FC236}">
+                <a16:creationId xmlns:a16="http://schemas.microsoft.com/office/drawing/2014/main" id="{BA1A3B32-3EF4-455D-921B-BCFC570BE910}"/>
+              </a:ext>
+            </a:extLst>
+          </p:cNvPr>
+          <p:cNvSpPr>
+            <a:spLocks xmlns:a="http://schemas.openxmlformats.org/drawingml/2006/main" noGrp="1"/>
+          </p:cNvSpPr>
+          <p:nvPr/>
+        </p:nvSpPr>
+        <p:spPr>
+          <a:xfrm xmlns:a="http://schemas.openxmlformats.org/drawingml/2006/main">
+            <a:off x="3943350" y="1695450"/>
+            <a:ext cx="1809750" cy="990600"/>
           </a:xfrm>
           <a:prstGeom xmlns:a="http://schemas.openxmlformats.org/drawingml/2006/main" prst="roundRect">
             <a:avLst>
-              <a:gd name="adj" fmla="val 22222"/>
+              <a:gd name="adj" fmla="val 15385"/>
+            </a:avLst>
+          </a:prstGeom>
+          <a:solidFill xmlns:a="http://schemas.openxmlformats.org/drawingml/2006/main">
+            <a:srgbClr val="E5F7EE"/>
+          </a:solidFill>
+          <a:ln xmlns:a="http://schemas.openxmlformats.org/drawingml/2006/main" w="14288">
+            <a:solidFill>
+              <a:srgbClr val="15845C"/>
+            </a:solidFill>
+            <a:prstDash val="solid"/>
+          </a:ln>
+        </p:spPr>
+        <p:style>
+          <a:lnRef xmlns:a="http://schemas.openxmlformats.org/drawingml/2006/main" idx="0"/>
+          <a:fillRef xmlns:a="http://schemas.openxmlformats.org/drawingml/2006/main" idx="0"/>
+          <a:effectRef xmlns:a="http://schemas.openxmlformats.org/drawingml/2006/main" idx="4"/>
+          <a:fontRef xmlns:a="http://schemas.openxmlformats.org/drawingml/2006/main" idx="major"/>
+        </p:style>
+        <p:txBody>
+          <a:bodyPr xmlns:a="http://schemas.openxmlformats.org/drawingml/2006/main" wrap="square" lIns="66675" tIns="66675" rIns="66675" bIns="66675" anchor="ctr">
+            <a:normAutofit fontScale="100000"/>
+          </a:bodyPr>
+          <a:lstStyle xmlns:a="http://schemas.openxmlformats.org/drawingml/2006/main"/>
+          <a:p xmlns:a="http://schemas.openxmlformats.org/drawingml/2006/main">
+            <a:pPr algn="ctr">
+              <a:defRPr sz="1013" b="1">
+                <a:solidFill>
+                  <a:srgbClr val="15845C"/>
+                </a:solidFill>
+                <a:latin typeface="Noto Sans JP Thin"/>
+                <a:ea typeface="Noto Sans JP Thin"/>
+                <a:cs typeface="Noto Sans JP Thin"/>
+              </a:defRPr>
+            </a:pPr>
+            <a:r>
+              <a:rPr sz="1013" b="1">
+                <a:solidFill>
+                  <a:srgbClr val="15845C"/>
+                </a:solidFill>
+                <a:latin typeface="Noto Sans JP Thin"/>
+                <a:ea typeface="Noto Sans JP Thin"/>
+                <a:cs typeface="Noto Sans JP Thin"/>
+              </a:rPr>
+              <a:t>決定的な専門判断コア</a:t>
+            </a:r>
+          </a:p>
+          <a:p xmlns:a="http://schemas.openxmlformats.org/drawingml/2006/main">
+            <a:pPr algn="ctr">
+              <a:defRPr sz="1013" b="1">
+                <a:solidFill>
+                  <a:srgbClr val="15845C"/>
+                </a:solidFill>
+                <a:latin typeface="Noto Sans JP Thin"/>
+                <a:ea typeface="Noto Sans JP Thin"/>
+                <a:cs typeface="Noto Sans JP Thin"/>
+              </a:defRPr>
+            </a:pPr>
+            <a:r>
+              <a:rPr sz="1013" b="1">
+                <a:solidFill>
+                  <a:srgbClr val="15845C"/>
+                </a:solidFill>
+                <a:latin typeface="Noto Sans JP Thin"/>
+                <a:ea typeface="Noto Sans JP Thin"/>
+                <a:cs typeface="Noto Sans JP Thin"/>
+              </a:rPr>
+              <a:t>必要資料・リスク・確認点</a:t>
+            </a:r>
+          </a:p>
+          <a:p xmlns:a="http://schemas.openxmlformats.org/drawingml/2006/main">
+            <a:pPr algn="ctr">
+              <a:defRPr sz="1013" b="1">
+                <a:solidFill>
+                  <a:srgbClr val="15845C"/>
+                </a:solidFill>
+                <a:latin typeface="Noto Sans JP Thin"/>
+                <a:ea typeface="Noto Sans JP Thin"/>
+                <a:cs typeface="Noto Sans JP Thin"/>
+              </a:defRPr>
+            </a:pPr>
+            <a:r>
+              <a:rPr sz="1013" b="1">
+                <a:solidFill>
+                  <a:srgbClr val="15845C"/>
+                </a:solidFill>
+                <a:latin typeface="Noto Sans JP Thin"/>
+                <a:ea typeface="Noto Sans JP Thin"/>
+                <a:cs typeface="Noto Sans JP Thin"/>
+              </a:rPr>
+              <a:t>書面案を同じ結果で作る</a:t>
+            </a:r>
+          </a:p>
+        </p:txBody>
+      </p:sp>
+      <p:sp>
+        <p:nvSpPr>
+          <p:cNvPr id="29" name="">
+            <a:extLst xmlns:a="http://schemas.openxmlformats.org/drawingml/2006/main">
+              <a:ext uri="{FF2B5EF4-FFF2-40B4-BE49-F238E27FC236}">
+                <a16:creationId xmlns:a16="http://schemas.microsoft.com/office/drawing/2014/main" id="{C4B9D71E-8579-44B6-BA6D-50DC156A72BF}"/>
+              </a:ext>
+            </a:extLst>
+          </p:cNvPr>
+          <p:cNvSpPr>
+            <a:spLocks xmlns:a="http://schemas.openxmlformats.org/drawingml/2006/main" noGrp="1"/>
+          </p:cNvSpPr>
+          <p:nvPr/>
+        </p:nvSpPr>
+        <p:spPr>
+          <a:xfrm xmlns:a="http://schemas.openxmlformats.org/drawingml/2006/main">
+            <a:off x="6153150" y="1695450"/>
+            <a:ext cx="1581150" cy="990600"/>
+          </a:xfrm>
+          <a:prstGeom xmlns:a="http://schemas.openxmlformats.org/drawingml/2006/main" prst="roundRect">
+            <a:avLst>
+              <a:gd name="adj" fmla="val 15385"/>
+            </a:avLst>
+          </a:prstGeom>
+          <a:solidFill xmlns:a="http://schemas.openxmlformats.org/drawingml/2006/main">
+            <a:srgbClr val="FFF0E8"/>
+          </a:solidFill>
+          <a:ln xmlns:a="http://schemas.openxmlformats.org/drawingml/2006/main" w="14288">
+            <a:solidFill>
+              <a:srgbClr val="C25B24"/>
+            </a:solidFill>
+            <a:prstDash val="solid"/>
+          </a:ln>
+        </p:spPr>
+        <p:style>
+          <a:lnRef xmlns:a="http://schemas.openxmlformats.org/drawingml/2006/main" idx="0"/>
+          <a:fillRef xmlns:a="http://schemas.openxmlformats.org/drawingml/2006/main" idx="0"/>
+          <a:effectRef xmlns:a="http://schemas.openxmlformats.org/drawingml/2006/main" idx="4"/>
+          <a:fontRef xmlns:a="http://schemas.openxmlformats.org/drawingml/2006/main" idx="major"/>
+        </p:style>
+        <p:txBody>
+          <a:bodyPr xmlns:a="http://schemas.openxmlformats.org/drawingml/2006/main" wrap="square" lIns="66675" tIns="66675" rIns="66675" bIns="66675" anchor="ctr">
+            <a:normAutofit fontScale="100000"/>
+          </a:bodyPr>
+          <a:lstStyle xmlns:a="http://schemas.openxmlformats.org/drawingml/2006/main"/>
+          <a:p xmlns:a="http://schemas.openxmlformats.org/drawingml/2006/main">
+            <a:pPr algn="ctr">
+              <a:defRPr sz="1050" b="1">
+                <a:solidFill>
+                  <a:srgbClr val="C25B24"/>
+                </a:solidFill>
+                <a:latin typeface="Noto Sans JP Thin"/>
+                <a:ea typeface="Noto Sans JP Thin"/>
+                <a:cs typeface="Noto Sans JP Thin"/>
+              </a:defRPr>
+            </a:pPr>
+            <a:r>
+              <a:rPr sz="1050" b="1">
+                <a:solidFill>
+                  <a:srgbClr val="C25B24"/>
+                </a:solidFill>
+                <a:latin typeface="Noto Sans JP Thin"/>
+                <a:ea typeface="Noto Sans JP Thin"/>
+                <a:cs typeface="Noto Sans JP Thin"/>
+              </a:rPr>
+              <a:t>税理士がレビュー</a:t>
+            </a:r>
+          </a:p>
+          <a:p xmlns:a="http://schemas.openxmlformats.org/drawingml/2006/main">
+            <a:pPr algn="ctr">
+              <a:defRPr sz="1050" b="1">
+                <a:solidFill>
+                  <a:srgbClr val="C25B24"/>
+                </a:solidFill>
+                <a:latin typeface="Noto Sans JP Thin"/>
+                <a:ea typeface="Noto Sans JP Thin"/>
+                <a:cs typeface="Noto Sans JP Thin"/>
+              </a:defRPr>
+            </a:pPr>
+            <a:r>
+              <a:rPr sz="1050" b="1">
+                <a:solidFill>
+                  <a:srgbClr val="C25B24"/>
+                </a:solidFill>
+                <a:latin typeface="Noto Sans JP Thin"/>
+                <a:ea typeface="Noto Sans JP Thin"/>
+                <a:cs typeface="Noto Sans JP Thin"/>
+              </a:rPr>
+              <a:t>適用可否・所見を確認</a:t>
+            </a:r>
+          </a:p>
+          <a:p xmlns:a="http://schemas.openxmlformats.org/drawingml/2006/main">
+            <a:pPr algn="ctr">
+              <a:defRPr sz="1050" b="1">
+                <a:solidFill>
+                  <a:srgbClr val="C25B24"/>
+                </a:solidFill>
+                <a:latin typeface="Noto Sans JP Thin"/>
+                <a:ea typeface="Noto Sans JP Thin"/>
+                <a:cs typeface="Noto Sans JP Thin"/>
+              </a:defRPr>
+            </a:pPr>
+            <a:r>
+              <a:rPr sz="1050" b="1">
+                <a:solidFill>
+                  <a:srgbClr val="C25B24"/>
+                </a:solidFill>
+                <a:latin typeface="Noto Sans JP Thin"/>
+                <a:ea typeface="Noto Sans JP Thin"/>
+                <a:cs typeface="Noto Sans JP Thin"/>
+              </a:rPr>
+              <a:t>人の責任で承認</a:t>
+            </a:r>
+          </a:p>
+        </p:txBody>
+      </p:sp>
+      <p:sp>
+        <p:nvSpPr>
+          <p:cNvPr id="30" name="">
+            <a:extLst xmlns:a="http://schemas.openxmlformats.org/drawingml/2006/main">
+              <a:ext uri="{FF2B5EF4-FFF2-40B4-BE49-F238E27FC236}">
+                <a16:creationId xmlns:a16="http://schemas.microsoft.com/office/drawing/2014/main" id="{C787E9F5-F33E-4D9A-87F3-53AA4EC484F9}"/>
+              </a:ext>
+            </a:extLst>
+          </p:cNvPr>
+          <p:cNvSpPr>
+            <a:spLocks xmlns:a="http://schemas.openxmlformats.org/drawingml/2006/main" noGrp="1"/>
+          </p:cNvSpPr>
+          <p:nvPr/>
+        </p:nvSpPr>
+        <p:spPr>
+          <a:xfrm xmlns:a="http://schemas.openxmlformats.org/drawingml/2006/main">
+            <a:off x="8134350" y="1695450"/>
+            <a:ext cx="1257300" cy="990600"/>
+          </a:xfrm>
+          <a:prstGeom xmlns:a="http://schemas.openxmlformats.org/drawingml/2006/main" prst="roundRect">
+            <a:avLst>
+              <a:gd name="adj" fmla="val 15385"/>
+            </a:avLst>
+          </a:prstGeom>
+          <a:solidFill xmlns:a="http://schemas.openxmlformats.org/drawingml/2006/main">
+            <a:srgbClr val="FFFFFF"/>
+          </a:solidFill>
+          <a:ln xmlns:a="http://schemas.openxmlformats.org/drawingml/2006/main" w="14288">
+            <a:solidFill>
+              <a:srgbClr val="17324D"/>
+            </a:solidFill>
+            <a:prstDash val="solid"/>
+          </a:ln>
+        </p:spPr>
+        <p:style>
+          <a:lnRef xmlns:a="http://schemas.openxmlformats.org/drawingml/2006/main" idx="0"/>
+          <a:fillRef xmlns:a="http://schemas.openxmlformats.org/drawingml/2006/main" idx="0"/>
+          <a:effectRef xmlns:a="http://schemas.openxmlformats.org/drawingml/2006/main" idx="4"/>
+          <a:fontRef xmlns:a="http://schemas.openxmlformats.org/drawingml/2006/main" idx="major"/>
+        </p:style>
+        <p:txBody>
+          <a:bodyPr xmlns:a="http://schemas.openxmlformats.org/drawingml/2006/main" wrap="square" lIns="66675" tIns="66675" rIns="66675" bIns="66675" anchor="ctr">
+            <a:normAutofit fontScale="100000"/>
+          </a:bodyPr>
+          <a:lstStyle xmlns:a="http://schemas.openxmlformats.org/drawingml/2006/main"/>
+          <a:p xmlns:a="http://schemas.openxmlformats.org/drawingml/2006/main">
+            <a:pPr algn="ctr">
+              <a:defRPr sz="1050" b="1">
+                <a:solidFill>
+                  <a:srgbClr val="17324D"/>
+                </a:solidFill>
+                <a:latin typeface="Noto Sans JP Thin"/>
+                <a:ea typeface="Noto Sans JP Thin"/>
+                <a:cs typeface="Noto Sans JP Thin"/>
+              </a:defRPr>
+            </a:pPr>
+            <a:r>
+              <a:rPr sz="1050" b="1">
+                <a:solidFill>
+                  <a:srgbClr val="17324D"/>
+                </a:solidFill>
+                <a:latin typeface="Noto Sans JP Thin"/>
+                <a:ea typeface="Noto Sans JP Thin"/>
+                <a:cs typeface="Noto Sans JP Thin"/>
+              </a:rPr>
+              <a:t>承認後のみ</a:t>
+            </a:r>
+          </a:p>
+          <a:p xmlns:a="http://schemas.openxmlformats.org/drawingml/2006/main">
+            <a:pPr algn="ctr">
+              <a:defRPr sz="1050" b="1">
+                <a:solidFill>
+                  <a:srgbClr val="17324D"/>
+                </a:solidFill>
+                <a:latin typeface="Noto Sans JP Thin"/>
+                <a:ea typeface="Noto Sans JP Thin"/>
+                <a:cs typeface="Noto Sans JP Thin"/>
+              </a:defRPr>
+            </a:pPr>
+            <a:r>
+              <a:rPr sz="1050" b="1">
+                <a:solidFill>
+                  <a:srgbClr val="17324D"/>
+                </a:solidFill>
+                <a:latin typeface="Noto Sans JP Thin"/>
+                <a:ea typeface="Noto Sans JP Thin"/>
+                <a:cs typeface="Noto Sans JP Thin"/>
+              </a:rPr>
+              <a:t>Word書面を出力</a:t>
+            </a:r>
+          </a:p>
+        </p:txBody>
+      </p:sp>
+      <p:sp>
+        <p:nvSpPr>
+          <p:cNvPr id="31" name="">
+            <a:extLst xmlns:a="http://schemas.openxmlformats.org/drawingml/2006/main">
+              <a:ext uri="{FF2B5EF4-FFF2-40B4-BE49-F238E27FC236}">
+                <a16:creationId xmlns:a16="http://schemas.microsoft.com/office/drawing/2014/main" id="{93B5B555-2A45-4FCB-B544-60BB78B0530B}"/>
+              </a:ext>
+            </a:extLst>
+          </p:cNvPr>
+          <p:cNvSpPr>
+            <a:spLocks xmlns:a="http://schemas.openxmlformats.org/drawingml/2006/main" noGrp="1"/>
+          </p:cNvSpPr>
+          <p:nvPr/>
+        </p:nvSpPr>
+        <p:spPr>
+          <a:xfrm xmlns:a="http://schemas.openxmlformats.org/drawingml/2006/main">
+            <a:off x="2038350" y="2952750"/>
+            <a:ext cx="5695950" cy="590550"/>
+          </a:xfrm>
+          <a:prstGeom xmlns:a="http://schemas.openxmlformats.org/drawingml/2006/main" prst="roundRect">
+            <a:avLst>
+              <a:gd name="adj" fmla="val 25806"/>
             </a:avLst>
           </a:prstGeom>
           <a:solidFill xmlns:a="http://schemas.openxmlformats.org/drawingml/2006/main">
@@ -4732,6 +5800,167 @@
             <a:prstDash val="solid"/>
           </a:ln>
         </p:spPr>
+        <p:style>
+          <a:lnRef xmlns:a="http://schemas.openxmlformats.org/drawingml/2006/main" idx="0"/>
+          <a:fillRef xmlns:a="http://schemas.openxmlformats.org/drawingml/2006/main" idx="0"/>
+          <a:effectRef xmlns:a="http://schemas.openxmlformats.org/drawingml/2006/main" idx="4"/>
+          <a:fontRef xmlns:a="http://schemas.openxmlformats.org/drawingml/2006/main" idx="major"/>
+        </p:style>
+        <p:txBody>
+          <a:bodyPr xmlns:a="http://schemas.openxmlformats.org/drawingml/2006/main" wrap="square" lIns="76200" tIns="47625" rIns="76200" bIns="47625" anchor="ctr">
+            <a:normAutofit fontScale="100000"/>
+          </a:bodyPr>
+          <a:lstStyle xmlns:a="http://schemas.openxmlformats.org/drawingml/2006/main"/>
+          <a:p xmlns:a="http://schemas.openxmlformats.org/drawingml/2006/main">
+            <a:pPr algn="ctr">
+              <a:defRPr sz="1125" b="1">
+                <a:solidFill>
+                  <a:srgbClr val="A66A00"/>
+                </a:solidFill>
+                <a:latin typeface="Noto Sans JP Thin"/>
+                <a:ea typeface="Noto Sans JP Thin"/>
+                <a:cs typeface="Noto Sans JP Thin"/>
+              </a:defRPr>
+            </a:pPr>
+            <a:r>
+              <a:rPr sz="1125" b="1">
+                <a:solidFill>
+                  <a:srgbClr val="A66A00"/>
+                </a:solidFill>
+                <a:latin typeface="Noto Sans JP Thin"/>
+                <a:ea typeface="Noto Sans JP Thin"/>
+                <a:cs typeface="Noto Sans JP Thin"/>
+              </a:rPr>
+              <a:t>情報不足・事実の矛盾・AI障害</a:t>
+            </a:r>
+          </a:p>
+          <a:p xmlns:a="http://schemas.openxmlformats.org/drawingml/2006/main">
+            <a:pPr algn="ctr">
+              <a:defRPr sz="1125" b="1">
+                <a:solidFill>
+                  <a:srgbClr val="A66A00"/>
+                </a:solidFill>
+                <a:latin typeface="Noto Sans JP Thin"/>
+                <a:ea typeface="Noto Sans JP Thin"/>
+                <a:cs typeface="Noto Sans JP Thin"/>
+              </a:defRPr>
+            </a:pPr>
+            <a:r>
+              <a:rPr sz="1125" b="1">
+                <a:solidFill>
+                  <a:srgbClr val="A66A00"/>
+                </a:solidFill>
+                <a:latin typeface="Noto Sans JP Thin"/>
+                <a:ea typeface="Noto Sans JP Thin"/>
+                <a:cs typeface="Noto Sans JP Thin"/>
+              </a:rPr>
+              <a:t>状態を変えずに安全停止し、追加回答後に同じ案件を再開</a:t>
+            </a:r>
+          </a:p>
+        </p:txBody>
+      </p:sp>
+      <p:sp>
+        <p:nvSpPr>
+          <p:cNvPr id="32" name="">
+            <a:extLst xmlns:a="http://schemas.openxmlformats.org/drawingml/2006/main">
+              <a:ext uri="{FF2B5EF4-FFF2-40B4-BE49-F238E27FC236}">
+                <a16:creationId xmlns:a16="http://schemas.microsoft.com/office/drawing/2014/main" id="{34842473-236B-44CA-8CA9-3CE49DF70E66}"/>
+              </a:ext>
+            </a:extLst>
+          </p:cNvPr>
+          <p:cNvSpPr>
+            <a:spLocks xmlns:a="http://schemas.openxmlformats.org/drawingml/2006/main" noGrp="1"/>
+          </p:cNvSpPr>
+          <p:nvPr/>
+        </p:nvSpPr>
+        <p:spPr>
+          <a:xfrm xmlns:a="http://schemas.openxmlformats.org/drawingml/2006/main">
+            <a:off x="3295650" y="3571875"/>
+            <a:ext cx="5581650" cy="209550"/>
+          </a:xfrm>
+          <a:prstGeom xmlns:a="http://schemas.openxmlformats.org/drawingml/2006/main" prst="roundRect">
+            <a:avLst>
+              <a:gd name="adj" fmla="val 50000"/>
+            </a:avLst>
+          </a:prstGeom>
+          <a:solidFill xmlns:a="http://schemas.openxmlformats.org/drawingml/2006/main">
+            <a:srgbClr val="EDF4F9"/>
+          </a:solidFill>
+          <a:ln xmlns:a="http://schemas.openxmlformats.org/drawingml/2006/main" w="0">
+            <a:noFill/>
+            <a:prstDash val="solid"/>
+          </a:ln>
+        </p:spPr>
+        <p:txBody>
+          <a:bodyPr xmlns:a="http://schemas.openxmlformats.org/drawingml/2006/main" wrap="square" lIns="95250" tIns="19050" rIns="95250" bIns="19050" anchor="ctr">
+            <a:normAutofit fontScale="83694"/>
+          </a:bodyPr>
+          <a:lstStyle xmlns:a="http://schemas.openxmlformats.org/drawingml/2006/main"/>
+          <a:p xmlns:a="http://schemas.openxmlformats.org/drawingml/2006/main">
+            <a:pPr algn="ctr">
+              <a:defRPr sz="863" b="1">
+                <a:solidFill>
+                  <a:srgbClr val="17324D"/>
+                </a:solidFill>
+                <a:latin typeface="Noto Sans JP Thin"/>
+                <a:ea typeface="Noto Sans JP Thin"/>
+                <a:cs typeface="Noto Sans JP Thin"/>
+              </a:defRPr>
+            </a:pPr>
+            <a:r>
+              <a:rPr sz="863" b="1">
+                <a:solidFill>
+                  <a:srgbClr val="17324D"/>
+                </a:solidFill>
+                <a:latin typeface="Noto Sans JP Thin"/>
+                <a:ea typeface="Noto Sans JP Thin"/>
+                <a:cs typeface="Noto Sans JP Thin"/>
+              </a:rPr>
+              <a:t>Cloud Runで公開｜訪問者ごとにセッションを分離｜公開デモの状態は一時保存</a:t>
+            </a:r>
+          </a:p>
+        </p:txBody>
+      </p:sp>
+      <p:sp>
+        <p:nvSpPr>
+          <p:cNvPr id="33" name="">
+            <a:extLst xmlns:a="http://schemas.openxmlformats.org/drawingml/2006/main">
+              <a:ext uri="{FF2B5EF4-FFF2-40B4-BE49-F238E27FC236}">
+                <a16:creationId xmlns:a16="http://schemas.microsoft.com/office/drawing/2014/main" id="{1D7271F7-90B0-4440-82E6-E2B1842DEC53}"/>
+              </a:ext>
+            </a:extLst>
+          </p:cNvPr>
+          <p:cNvSpPr>
+            <a:spLocks xmlns:a="http://schemas.openxmlformats.org/drawingml/2006/main" noGrp="1"/>
+          </p:cNvSpPr>
+          <p:nvPr/>
+        </p:nvSpPr>
+        <p:spPr>
+          <a:xfrm xmlns:a="http://schemas.openxmlformats.org/drawingml/2006/main">
+            <a:off x="1657350" y="4400550"/>
+            <a:ext cx="1676400" cy="590550"/>
+          </a:xfrm>
+          <a:prstGeom xmlns:a="http://schemas.openxmlformats.org/drawingml/2006/main" prst="roundRect">
+            <a:avLst>
+              <a:gd name="adj" fmla="val 25806"/>
+            </a:avLst>
+          </a:prstGeom>
+          <a:solidFill xmlns:a="http://schemas.openxmlformats.org/drawingml/2006/main">
+            <a:srgbClr val="FFFFFF"/>
+          </a:solidFill>
+          <a:ln xmlns:a="http://schemas.openxmlformats.org/drawingml/2006/main" w="14288">
+            <a:solidFill>
+              <a:srgbClr val="17324D"/>
+            </a:solidFill>
+            <a:prstDash val="solid"/>
+          </a:ln>
+        </p:spPr>
+        <p:style>
+          <a:lnRef xmlns:a="http://schemas.openxmlformats.org/drawingml/2006/main" idx="0"/>
+          <a:fillRef xmlns:a="http://schemas.openxmlformats.org/drawingml/2006/main" idx="0"/>
+          <a:effectRef xmlns:a="http://schemas.openxmlformats.org/drawingml/2006/main" idx="4"/>
+          <a:fontRef xmlns:a="http://schemas.openxmlformats.org/drawingml/2006/main" idx="major"/>
+        </p:style>
         <p:txBody>
           <a:bodyPr xmlns:a="http://schemas.openxmlformats.org/drawingml/2006/main" wrap="square" lIns="57150" tIns="47625" rIns="57150" bIns="47625" anchor="ctr">
             <a:normAutofit fontScale="100000"/>
@@ -4739,97 +5968,74 @@
           <a:lstStyle xmlns:a="http://schemas.openxmlformats.org/drawingml/2006/main"/>
           <a:p xmlns:a="http://schemas.openxmlformats.org/drawingml/2006/main">
             <a:pPr algn="ctr">
-              <a:defRPr sz="1050" b="1">
-                <a:solidFill>
-                  <a:srgbClr val="A66A00"/>
-                </a:solidFill>
-                <a:latin typeface="Noto Sans JP Thin"/>
-                <a:ea typeface="Noto Sans JP Thin"/>
-                <a:cs typeface="Noto Sans JP Thin"/>
-              </a:defRPr>
-            </a:pPr>
-            <a:r>
-              <a:rPr sz="1050" b="1">
-                <a:solidFill>
-                  <a:srgbClr val="A66A00"/>
-                </a:solidFill>
-                <a:latin typeface="Noto Sans JP Thin"/>
-                <a:ea typeface="Noto Sans JP Thin"/>
-                <a:cs typeface="Noto Sans JP Thin"/>
-              </a:rPr>
-              <a:t>SAFE STOP</a:t>
+              <a:defRPr sz="1125" b="1">
+                <a:solidFill>
+                  <a:srgbClr val="17324D"/>
+                </a:solidFill>
+                <a:latin typeface="Noto Sans JP Thin"/>
+                <a:ea typeface="Noto Sans JP Thin"/>
+                <a:cs typeface="Noto Sans JP Thin"/>
+              </a:defRPr>
+            </a:pPr>
+            <a:r>
+              <a:rPr sz="1125" b="1">
+                <a:solidFill>
+                  <a:srgbClr val="17324D"/>
+                </a:solidFill>
+                <a:latin typeface="Noto Sans JP Thin"/>
+                <a:ea typeface="Noto Sans JP Thin"/>
+                <a:cs typeface="Noto Sans JP Thin"/>
+              </a:rPr>
+              <a:t>専門知ルールを</a:t>
             </a:r>
           </a:p>
           <a:p xmlns:a="http://schemas.openxmlformats.org/drawingml/2006/main">
             <a:pPr algn="ctr">
-              <a:defRPr sz="1050" b="1">
-                <a:solidFill>
-                  <a:srgbClr val="A66A00"/>
-                </a:solidFill>
-                <a:latin typeface="Noto Sans JP Thin"/>
-                <a:ea typeface="Noto Sans JP Thin"/>
-                <a:cs typeface="Noto Sans JP Thin"/>
-              </a:defRPr>
-            </a:pPr>
-            <a:r>
-              <a:rPr sz="1050" b="1">
-                <a:solidFill>
-                  <a:srgbClr val="A66A00"/>
-                </a:solidFill>
-                <a:latin typeface="Noto Sans JP Thin"/>
-                <a:ea typeface="Noto Sans JP Thin"/>
-                <a:cs typeface="Noto Sans JP Thin"/>
-              </a:rPr>
-              <a:t>案件state不変</a:t>
-            </a:r>
-          </a:p>
-          <a:p xmlns:a="http://schemas.openxmlformats.org/drawingml/2006/main">
-            <a:pPr algn="ctr">
-              <a:defRPr sz="1050" b="1">
-                <a:solidFill>
-                  <a:srgbClr val="A66A00"/>
-                </a:solidFill>
-                <a:latin typeface="Noto Sans JP Thin"/>
-                <a:ea typeface="Noto Sans JP Thin"/>
-                <a:cs typeface="Noto Sans JP Thin"/>
-              </a:defRPr>
-            </a:pPr>
-            <a:r>
-              <a:rPr sz="1050" b="1">
-                <a:solidFill>
-                  <a:srgbClr val="A66A00"/>
-                </a:solidFill>
-                <a:latin typeface="Noto Sans JP Thin"/>
-                <a:ea typeface="Noto Sans JP Thin"/>
-                <a:cs typeface="Noto Sans JP Thin"/>
-              </a:rPr>
-              <a:t>Review・Wordロック</a:t>
-            </a:r>
-          </a:p>
-        </p:txBody>
-      </p:sp>
-      <p:sp>
-        <p:nvSpPr>
-          <p:cNvPr id="11" name="">
-            <a:extLst xmlns:a="http://schemas.openxmlformats.org/drawingml/2006/main">
-              <a:ext uri="{FF2B5EF4-FFF2-40B4-BE49-F238E27FC236}">
-                <a16:creationId xmlns:a16="http://schemas.microsoft.com/office/drawing/2014/main" id="{6EC0F5FF-FFD4-4870-B5FC-7802334C0FFA}"/>
-              </a:ext>
-            </a:extLst>
-          </p:cNvPr>
-          <p:cNvSpPr>
-            <a:spLocks xmlns:a="http://schemas.openxmlformats.org/drawingml/2006/main" noGrp="1"/>
-          </p:cNvSpPr>
-          <p:nvPr/>
-        </p:nvSpPr>
-        <p:spPr>
-          <a:xfrm xmlns:a="http://schemas.openxmlformats.org/drawingml/2006/main">
-            <a:off x="4000500" y="1581150"/>
-            <a:ext cx="2000250" cy="1314450"/>
+              <a:defRPr sz="1125" b="1">
+                <a:solidFill>
+                  <a:srgbClr val="17324D"/>
+                </a:solidFill>
+                <a:latin typeface="Noto Sans JP Thin"/>
+                <a:ea typeface="Noto Sans JP Thin"/>
+                <a:cs typeface="Noto Sans JP Thin"/>
+              </a:defRPr>
+            </a:pPr>
+            <a:r>
+              <a:rPr sz="1125" b="1">
+                <a:solidFill>
+                  <a:srgbClr val="17324D"/>
+                </a:solidFill>
+                <a:latin typeface="Noto Sans JP Thin"/>
+                <a:ea typeface="Noto Sans JP Thin"/>
+                <a:cs typeface="Noto Sans JP Thin"/>
+              </a:rPr>
+              <a:t>GitHubで更新</a:t>
+            </a:r>
+          </a:p>
+        </p:txBody>
+      </p:sp>
+      <p:sp>
+        <p:nvSpPr>
+          <p:cNvPr id="34" name="">
+            <a:extLst xmlns:a="http://schemas.openxmlformats.org/drawingml/2006/main">
+              <a:ext uri="{FF2B5EF4-FFF2-40B4-BE49-F238E27FC236}">
+                <a16:creationId xmlns:a16="http://schemas.microsoft.com/office/drawing/2014/main" id="{317FA56B-C520-41C3-AA6B-289DCC6A79F0}"/>
+              </a:ext>
+            </a:extLst>
+          </p:cNvPr>
+          <p:cNvSpPr>
+            <a:spLocks xmlns:a="http://schemas.openxmlformats.org/drawingml/2006/main" noGrp="1"/>
+          </p:cNvSpPr>
+          <p:nvPr/>
+        </p:nvSpPr>
+        <p:spPr>
+          <a:xfrm xmlns:a="http://schemas.openxmlformats.org/drawingml/2006/main">
+            <a:off x="3600450" y="4362450"/>
+            <a:ext cx="2686050" cy="666750"/>
           </a:xfrm>
           <a:prstGeom xmlns:a="http://schemas.openxmlformats.org/drawingml/2006/main" prst="roundRect">
             <a:avLst>
-              <a:gd name="adj" fmla="val 11594"/>
+              <a:gd name="adj" fmla="val 22857"/>
             </a:avLst>
           </a:prstGeom>
           <a:solidFill xmlns:a="http://schemas.openxmlformats.org/drawingml/2006/main">
@@ -4842,14 +6048,20 @@
             <a:prstDash val="solid"/>
           </a:ln>
         </p:spPr>
-        <p:txBody>
-          <a:bodyPr xmlns:a="http://schemas.openxmlformats.org/drawingml/2006/main" wrap="square" lIns="76200" tIns="76200" rIns="76200" bIns="76200" anchor="ctr">
+        <p:style>
+          <a:lnRef xmlns:a="http://schemas.openxmlformats.org/drawingml/2006/main" idx="0"/>
+          <a:fillRef xmlns:a="http://schemas.openxmlformats.org/drawingml/2006/main" idx="0"/>
+          <a:effectRef xmlns:a="http://schemas.openxmlformats.org/drawingml/2006/main" idx="4"/>
+          <a:fontRef xmlns:a="http://schemas.openxmlformats.org/drawingml/2006/main" idx="major"/>
+        </p:style>
+        <p:txBody>
+          <a:bodyPr xmlns:a="http://schemas.openxmlformats.org/drawingml/2006/main" wrap="square" lIns="66675" tIns="47625" rIns="66675" bIns="47625" anchor="ctr">
             <a:normAutofit fontScale="100000"/>
           </a:bodyPr>
           <a:lstStyle xmlns:a="http://schemas.openxmlformats.org/drawingml/2006/main"/>
           <a:p xmlns:a="http://schemas.openxmlformats.org/drawingml/2006/main">
             <a:pPr algn="ctr">
-              <a:defRPr sz="1125" b="1">
+              <a:defRPr sz="1050" b="1">
                 <a:solidFill>
                   <a:srgbClr val="15845C"/>
                 </a:solidFill>
@@ -4859,7 +6071,7 @@
               </a:defRPr>
             </a:pPr>
             <a:r>
-              <a:rPr sz="1125" b="1">
+              <a:rPr sz="1050" b="1">
                 <a:solidFill>
                   <a:srgbClr val="15845C"/>
                 </a:solidFill>
@@ -4867,12 +6079,12 @@
                 <a:ea typeface="Noto Sans JP Thin"/>
                 <a:cs typeface="Noto Sans JP Thin"/>
               </a:rPr>
-              <a:t>決定的要件整理コア</a:t>
+              <a:t>GitHub Actionsで自動検証</a:t>
             </a:r>
           </a:p>
           <a:p xmlns:a="http://schemas.openxmlformats.org/drawingml/2006/main">
             <a:pPr algn="ctr">
-              <a:defRPr sz="1125" b="1">
+              <a:defRPr sz="1050" b="1">
                 <a:solidFill>
                   <a:srgbClr val="15845C"/>
                 </a:solidFill>
@@ -4882,7 +6094,7 @@
               </a:defRPr>
             </a:pPr>
             <a:r>
-              <a:rPr sz="1125" b="1">
+              <a:rPr sz="1050" b="1">
                 <a:solidFill>
                   <a:srgbClr val="15845C"/>
                 </a:solidFill>
@@ -4890,698 +6102,37 @@
                 <a:ea typeface="Noto Sans JP Thin"/>
                 <a:cs typeface="Noto Sans JP Thin"/>
               </a:rPr>
-              <a:t>rules + reducer</a:t>
-            </a:r>
-          </a:p>
-          <a:p xmlns:a="http://schemas.openxmlformats.org/drawingml/2006/main">
-            <a:r>
-              <a:t/>
-            </a:r>
-          </a:p>
-          <a:p xmlns:a="http://schemas.openxmlformats.org/drawingml/2006/main">
-            <a:pPr algn="ctr">
-              <a:defRPr sz="1125" b="1">
-                <a:solidFill>
-                  <a:srgbClr val="15845C"/>
-                </a:solidFill>
-                <a:latin typeface="Noto Sans JP Thin"/>
-                <a:ea typeface="Noto Sans JP Thin"/>
-                <a:cs typeface="Noto Sans JP Thin"/>
-              </a:defRPr>
-            </a:pPr>
-            <a:r>
-              <a:rPr sz="1125" b="1">
-                <a:solidFill>
-                  <a:srgbClr val="15845C"/>
-                </a:solidFill>
-                <a:latin typeface="Noto Sans JP Thin"/>
-                <a:ea typeface="Noto Sans JP Thin"/>
-                <a:cs typeface="Noto Sans JP Thin"/>
-              </a:rPr>
-              <a:t>不足資料・リスク</a:t>
-            </a:r>
-          </a:p>
-          <a:p xmlns:a="http://schemas.openxmlformats.org/drawingml/2006/main">
-            <a:pPr algn="ctr">
-              <a:defRPr sz="1125" b="1">
-                <a:solidFill>
-                  <a:srgbClr val="15845C"/>
-                </a:solidFill>
-                <a:latin typeface="Noto Sans JP Thin"/>
-                <a:ea typeface="Noto Sans JP Thin"/>
-                <a:cs typeface="Noto Sans JP Thin"/>
-              </a:defRPr>
-            </a:pPr>
-            <a:r>
-              <a:rPr sz="1125" b="1">
-                <a:solidFill>
-                  <a:srgbClr val="15845C"/>
-                </a:solidFill>
-                <a:latin typeface="Noto Sans JP Thin"/>
-                <a:ea typeface="Noto Sans JP Thin"/>
-                <a:cs typeface="Noto Sans JP Thin"/>
-              </a:rPr>
-              <a:t>反実仮想・書面ドラフト</a:t>
-            </a:r>
-          </a:p>
-        </p:txBody>
-      </p:sp>
-      <p:sp>
-        <p:nvSpPr>
-          <p:cNvPr id="12" name="">
-            <a:extLst xmlns:a="http://schemas.openxmlformats.org/drawingml/2006/main">
-              <a:ext uri="{FF2B5EF4-FFF2-40B4-BE49-F238E27FC236}">
-                <a16:creationId xmlns:a16="http://schemas.microsoft.com/office/drawing/2014/main" id="{50D8385C-1A2A-46A2-AB51-D94E654BC486}"/>
-              </a:ext>
-            </a:extLst>
-          </p:cNvPr>
-          <p:cNvSpPr>
-            <a:spLocks xmlns:a="http://schemas.openxmlformats.org/drawingml/2006/main" noGrp="1"/>
-          </p:cNvSpPr>
-          <p:nvPr/>
-        </p:nvSpPr>
-        <p:spPr>
-          <a:xfrm xmlns:a="http://schemas.openxmlformats.org/drawingml/2006/main">
-            <a:off x="6381750" y="1733550"/>
-            <a:ext cx="1666875" cy="1162050"/>
+              <a:t>秘密情報検査 → 72テスト → コンテナ起動確認</a:t>
+            </a:r>
+          </a:p>
+        </p:txBody>
+      </p:sp>
+      <p:sp>
+        <p:nvSpPr>
+          <p:cNvPr id="35" name="">
+            <a:extLst xmlns:a="http://schemas.openxmlformats.org/drawingml/2006/main">
+              <a:ext uri="{FF2B5EF4-FFF2-40B4-BE49-F238E27FC236}">
+                <a16:creationId xmlns:a16="http://schemas.microsoft.com/office/drawing/2014/main" id="{C7D93B38-480F-4844-9914-78114E706FE1}"/>
+              </a:ext>
+            </a:extLst>
+          </p:cNvPr>
+          <p:cNvSpPr>
+            <a:spLocks xmlns:a="http://schemas.openxmlformats.org/drawingml/2006/main" noGrp="1"/>
+          </p:cNvSpPr>
+          <p:nvPr/>
+        </p:nvSpPr>
+        <p:spPr>
+          <a:xfrm xmlns:a="http://schemas.openxmlformats.org/drawingml/2006/main">
+            <a:off x="6553200" y="4400550"/>
+            <a:ext cx="2324100" cy="590550"/>
           </a:xfrm>
           <a:prstGeom xmlns:a="http://schemas.openxmlformats.org/drawingml/2006/main" prst="roundRect">
             <a:avLst>
-              <a:gd name="adj" fmla="val 13115"/>
-            </a:avLst>
-          </a:prstGeom>
-          <a:solidFill xmlns:a="http://schemas.openxmlformats.org/drawingml/2006/main">
-            <a:srgbClr val="FFF0E8"/>
-          </a:solidFill>
-          <a:ln xmlns:a="http://schemas.openxmlformats.org/drawingml/2006/main" w="14288">
-            <a:solidFill>
-              <a:srgbClr val="C25B24"/>
-            </a:solidFill>
-            <a:prstDash val="solid"/>
-          </a:ln>
-        </p:spPr>
-        <p:txBody>
-          <a:bodyPr xmlns:a="http://schemas.openxmlformats.org/drawingml/2006/main" wrap="square" lIns="76200" tIns="76200" rIns="76200" bIns="76200" anchor="ctr">
-            <a:normAutofit fontScale="100000"/>
-          </a:bodyPr>
-          <a:lstStyle xmlns:a="http://schemas.openxmlformats.org/drawingml/2006/main"/>
-          <a:p xmlns:a="http://schemas.openxmlformats.org/drawingml/2006/main">
-            <a:pPr algn="ctr">
-              <a:defRPr sz="1125" b="1">
-                <a:solidFill>
-                  <a:srgbClr val="C25B24"/>
-                </a:solidFill>
-                <a:latin typeface="Noto Sans JP Thin"/>
-                <a:ea typeface="Noto Sans JP Thin"/>
-                <a:cs typeface="Noto Sans JP Thin"/>
-              </a:defRPr>
-            </a:pPr>
-            <a:r>
-              <a:rPr sz="1125" b="1">
-                <a:solidFill>
-                  <a:srgbClr val="C25B24"/>
-                </a:solidFill>
-                <a:latin typeface="Noto Sans JP Thin"/>
-                <a:ea typeface="Noto Sans JP Thin"/>
-                <a:cs typeface="Noto Sans JP Thin"/>
-              </a:rPr>
-              <a:t>税理士Review</a:t>
-            </a:r>
-          </a:p>
-          <a:p xmlns:a="http://schemas.openxmlformats.org/drawingml/2006/main">
-            <a:pPr algn="ctr">
-              <a:defRPr sz="1125" b="1">
-                <a:solidFill>
-                  <a:srgbClr val="C25B24"/>
-                </a:solidFill>
-                <a:latin typeface="Noto Sans JP Thin"/>
-                <a:ea typeface="Noto Sans JP Thin"/>
-                <a:cs typeface="Noto Sans JP Thin"/>
-              </a:defRPr>
-            </a:pPr>
-            <a:r>
-              <a:rPr sz="1125" b="1">
-                <a:solidFill>
-                  <a:srgbClr val="C25B24"/>
-                </a:solidFill>
-                <a:latin typeface="Noto Sans JP Thin"/>
-                <a:ea typeface="Noto Sans JP Thin"/>
-                <a:cs typeface="Noto Sans JP Thin"/>
-              </a:rPr>
-              <a:t>適用可否・総合所見</a:t>
-            </a:r>
-          </a:p>
-          <a:p xmlns:a="http://schemas.openxmlformats.org/drawingml/2006/main">
-            <a:pPr algn="ctr">
-              <a:defRPr sz="1125" b="1">
-                <a:solidFill>
-                  <a:srgbClr val="C25B24"/>
-                </a:solidFill>
-                <a:latin typeface="Noto Sans JP Thin"/>
-                <a:ea typeface="Noto Sans JP Thin"/>
-                <a:cs typeface="Noto Sans JP Thin"/>
-              </a:defRPr>
-            </a:pPr>
-            <a:r>
-              <a:rPr sz="1125" b="1">
-                <a:solidFill>
-                  <a:srgbClr val="C25B24"/>
-                </a:solidFill>
-                <a:latin typeface="Noto Sans JP Thin"/>
-                <a:ea typeface="Noto Sans JP Thin"/>
-                <a:cs typeface="Noto Sans JP Thin"/>
-              </a:rPr>
-              <a:t>HITL承認ゲート</a:t>
-            </a:r>
-          </a:p>
-        </p:txBody>
-      </p:sp>
-      <p:sp>
-        <p:nvSpPr>
-          <p:cNvPr id="13" name="">
-            <a:extLst xmlns:a="http://schemas.openxmlformats.org/drawingml/2006/main">
-              <a:ext uri="{FF2B5EF4-FFF2-40B4-BE49-F238E27FC236}">
-                <a16:creationId xmlns:a16="http://schemas.microsoft.com/office/drawing/2014/main" id="{BBE7138D-FB85-4405-A66A-4A7FE1152327}"/>
-              </a:ext>
-            </a:extLst>
-          </p:cNvPr>
-          <p:cNvSpPr>
-            <a:spLocks xmlns:a="http://schemas.openxmlformats.org/drawingml/2006/main" noGrp="1"/>
-          </p:cNvSpPr>
-          <p:nvPr/>
-        </p:nvSpPr>
-        <p:spPr>
-          <a:xfrm xmlns:a="http://schemas.openxmlformats.org/drawingml/2006/main">
-            <a:off x="8248650" y="1828800"/>
-            <a:ext cx="1123950" cy="990600"/>
-          </a:xfrm>
-          <a:prstGeom xmlns:a="http://schemas.openxmlformats.org/drawingml/2006/main" prst="roundRect">
-            <a:avLst>
-              <a:gd name="adj" fmla="val 15385"/>
+              <a:gd name="adj" fmla="val 25806"/>
             </a:avLst>
           </a:prstGeom>
           <a:solidFill xmlns:a="http://schemas.openxmlformats.org/drawingml/2006/main">
             <a:srgbClr val="FFFFFF"/>
-          </a:solidFill>
-          <a:ln xmlns:a="http://schemas.openxmlformats.org/drawingml/2006/main" w="14288">
-            <a:solidFill>
-              <a:srgbClr val="17324D"/>
-            </a:solidFill>
-            <a:prstDash val="solid"/>
-          </a:ln>
-        </p:spPr>
-        <p:txBody>
-          <a:bodyPr xmlns:a="http://schemas.openxmlformats.org/drawingml/2006/main" wrap="square" lIns="57150" tIns="57150" rIns="57150" bIns="57150" anchor="ctr">
-            <a:normAutofit fontScale="100000"/>
-          </a:bodyPr>
-          <a:lstStyle xmlns:a="http://schemas.openxmlformats.org/drawingml/2006/main"/>
-          <a:p xmlns:a="http://schemas.openxmlformats.org/drawingml/2006/main">
-            <a:pPr algn="ctr">
-              <a:defRPr sz="1050" b="1">
-                <a:solidFill>
-                  <a:srgbClr val="17324D"/>
-                </a:solidFill>
-                <a:latin typeface="Noto Sans JP Thin"/>
-                <a:ea typeface="Noto Sans JP Thin"/>
-                <a:cs typeface="Noto Sans JP Thin"/>
-              </a:defRPr>
-            </a:pPr>
-            <a:r>
-              <a:rPr sz="1050" b="1">
-                <a:solidFill>
-                  <a:srgbClr val="17324D"/>
-                </a:solidFill>
-                <a:latin typeface="Noto Sans JP Thin"/>
-                <a:ea typeface="Noto Sans JP Thin"/>
-                <a:cs typeface="Noto Sans JP Thin"/>
-              </a:rPr>
-              <a:t>承認後のみ</a:t>
-            </a:r>
-          </a:p>
-          <a:p xmlns:a="http://schemas.openxmlformats.org/drawingml/2006/main">
-            <a:pPr algn="ctr">
-              <a:defRPr sz="1050" b="1">
-                <a:solidFill>
-                  <a:srgbClr val="17324D"/>
-                </a:solidFill>
-                <a:latin typeface="Noto Sans JP Thin"/>
-                <a:ea typeface="Noto Sans JP Thin"/>
-                <a:cs typeface="Noto Sans JP Thin"/>
-              </a:defRPr>
-            </a:pPr>
-            <a:r>
-              <a:rPr sz="1050" b="1">
-                <a:solidFill>
-                  <a:srgbClr val="17324D"/>
-                </a:solidFill>
-                <a:latin typeface="Noto Sans JP Thin"/>
-                <a:ea typeface="Noto Sans JP Thin"/>
-                <a:cs typeface="Noto Sans JP Thin"/>
-              </a:rPr>
-              <a:t>書面添付 .docx</a:t>
-            </a:r>
-          </a:p>
-          <a:p xmlns:a="http://schemas.openxmlformats.org/drawingml/2006/main">
-            <a:pPr algn="ctr">
-              <a:defRPr sz="1050" b="1">
-                <a:solidFill>
-                  <a:srgbClr val="17324D"/>
-                </a:solidFill>
-                <a:latin typeface="Noto Sans JP Thin"/>
-                <a:ea typeface="Noto Sans JP Thin"/>
-                <a:cs typeface="Noto Sans JP Thin"/>
-              </a:defRPr>
-            </a:pPr>
-            <a:r>
-              <a:rPr sz="1050" b="1">
-                <a:solidFill>
-                  <a:srgbClr val="17324D"/>
-                </a:solidFill>
-                <a:latin typeface="Noto Sans JP Thin"/>
-                <a:ea typeface="Noto Sans JP Thin"/>
-                <a:cs typeface="Noto Sans JP Thin"/>
-              </a:rPr>
-              <a:t>ドラフト出力</a:t>
-            </a:r>
-          </a:p>
-        </p:txBody>
-      </p:sp>
-      <p:cxnSp>
-        <p:nvCxnSpPr>
-          <p:cNvPr id="42" name=""/>
-          <p:cNvCxnSpPr>
-            <a:stCxn xmlns:a="http://schemas.openxmlformats.org/drawingml/2006/main" id="7" idx="3"/>
-            <a:endCxn xmlns:a="http://schemas.openxmlformats.org/drawingml/2006/main" id="8" idx="1"/>
-          </p:cNvCxnSpPr>
-          <p:nvPr/>
-        </p:nvCxnSpPr>
-        <p:spPr>
-          <a:xfrm xmlns:a="http://schemas.openxmlformats.org/drawingml/2006/main" flipV="1">
-            <a:off x="1504950" y="2238375"/>
-            <a:ext cx="476250" cy="95250"/>
-          </a:xfrm>
-          <a:prstGeom xmlns:a="http://schemas.openxmlformats.org/drawingml/2006/main" prst="straightConnector1">
-            <a:avLst/>
-          </a:prstGeom>
-          <a:ln xmlns:a="http://schemas.openxmlformats.org/drawingml/2006/main" w="23813">
-            <a:solidFill>
-              <a:srgbClr val="17324D"/>
-            </a:solidFill>
-            <a:prstDash val="solid"/>
-            <a:tailEnd type="triangle" w="sm" len="sm"/>
-          </a:ln>
-        </p:spPr>
-      </p:cxnSp>
-      <p:cxnSp>
-        <p:nvCxnSpPr>
-          <p:cNvPr id="43" name=""/>
-          <p:cNvCxnSpPr>
-            <a:stCxn xmlns:a="http://schemas.openxmlformats.org/drawingml/2006/main" id="8" idx="3"/>
-            <a:endCxn xmlns:a="http://schemas.openxmlformats.org/drawingml/2006/main" id="11" idx="1"/>
-          </p:cNvCxnSpPr>
-          <p:nvPr/>
-        </p:nvCxnSpPr>
-        <p:spPr>
-          <a:xfrm xmlns:a="http://schemas.openxmlformats.org/drawingml/2006/main">
-            <a:off x="3657600" y="2238375"/>
-            <a:ext cx="342900" cy="0"/>
-          </a:xfrm>
-          <a:prstGeom xmlns:a="http://schemas.openxmlformats.org/drawingml/2006/main" prst="straightConnector1">
-            <a:avLst/>
-          </a:prstGeom>
-          <a:ln xmlns:a="http://schemas.openxmlformats.org/drawingml/2006/main" w="23813">
-            <a:solidFill>
-              <a:srgbClr val="15845C"/>
-            </a:solidFill>
-            <a:prstDash val="solid"/>
-            <a:tailEnd type="triangle" w="sm" len="sm"/>
-          </a:ln>
-        </p:spPr>
-      </p:cxnSp>
-      <p:cxnSp>
-        <p:nvCxnSpPr>
-          <p:cNvPr id="44" name=""/>
-          <p:cNvCxnSpPr>
-            <a:stCxn xmlns:a="http://schemas.openxmlformats.org/drawingml/2006/main" id="11" idx="3"/>
-            <a:endCxn xmlns:a="http://schemas.openxmlformats.org/drawingml/2006/main" id="12" idx="1"/>
-          </p:cNvCxnSpPr>
-          <p:nvPr/>
-        </p:nvCxnSpPr>
-        <p:spPr>
-          <a:xfrm xmlns:a="http://schemas.openxmlformats.org/drawingml/2006/main">
-            <a:off x="6000750" y="2238375"/>
-            <a:ext cx="381000" cy="76200"/>
-          </a:xfrm>
-          <a:prstGeom xmlns:a="http://schemas.openxmlformats.org/drawingml/2006/main" prst="straightConnector1">
-            <a:avLst/>
-          </a:prstGeom>
-          <a:ln xmlns:a="http://schemas.openxmlformats.org/drawingml/2006/main" w="23813">
-            <a:solidFill>
-              <a:srgbClr val="15845C"/>
-            </a:solidFill>
-            <a:prstDash val="solid"/>
-            <a:tailEnd type="triangle" w="sm" len="sm"/>
-          </a:ln>
-        </p:spPr>
-      </p:cxnSp>
-      <p:cxnSp>
-        <p:nvCxnSpPr>
-          <p:cNvPr id="45" name=""/>
-          <p:cNvCxnSpPr>
-            <a:stCxn xmlns:a="http://schemas.openxmlformats.org/drawingml/2006/main" id="12" idx="3"/>
-            <a:endCxn xmlns:a="http://schemas.openxmlformats.org/drawingml/2006/main" id="13" idx="1"/>
-          </p:cNvCxnSpPr>
-          <p:nvPr/>
-        </p:nvCxnSpPr>
-        <p:spPr>
-          <a:xfrm xmlns:a="http://schemas.openxmlformats.org/drawingml/2006/main">
-            <a:off x="8048625" y="2314575"/>
-            <a:ext cx="200025" cy="9525"/>
-          </a:xfrm>
-          <a:prstGeom xmlns:a="http://schemas.openxmlformats.org/drawingml/2006/main" prst="straightConnector1">
-            <a:avLst/>
-          </a:prstGeom>
-          <a:ln xmlns:a="http://schemas.openxmlformats.org/drawingml/2006/main" w="23813">
-            <a:solidFill>
-              <a:srgbClr val="C25B24"/>
-            </a:solidFill>
-            <a:prstDash val="solid"/>
-            <a:tailEnd type="triangle" w="sm" len="sm"/>
-          </a:ln>
-        </p:spPr>
-      </p:cxnSp>
-      <p:cxnSp>
-        <p:nvCxnSpPr>
-          <p:cNvPr id="46" name=""/>
-          <p:cNvCxnSpPr>
-            <a:stCxn xmlns:a="http://schemas.openxmlformats.org/drawingml/2006/main" id="8" idx="0"/>
-            <a:endCxn xmlns:a="http://schemas.openxmlformats.org/drawingml/2006/main" id="9" idx="2"/>
-          </p:cNvCxnSpPr>
-          <p:nvPr/>
-        </p:nvCxnSpPr>
-        <p:spPr>
-          <a:xfrm xmlns:a="http://schemas.openxmlformats.org/drawingml/2006/main" flipV="1">
-            <a:off x="2819400" y="1543050"/>
-            <a:ext cx="0" cy="38100"/>
-          </a:xfrm>
-          <a:prstGeom xmlns:a="http://schemas.openxmlformats.org/drawingml/2006/main" prst="straightConnector1">
-            <a:avLst/>
-          </a:prstGeom>
-          <a:ln xmlns:a="http://schemas.openxmlformats.org/drawingml/2006/main" w="23813">
-            <a:solidFill>
-              <a:srgbClr val="7356C8"/>
-            </a:solidFill>
-            <a:prstDash val="solid"/>
-            <a:headEnd type="triangle" w="sm" len="sm"/>
-            <a:tailEnd type="triangle" w="sm" len="sm"/>
-          </a:ln>
-        </p:spPr>
-      </p:cxnSp>
-      <p:cxnSp>
-        <p:nvCxnSpPr>
-          <p:cNvPr id="47" name=""/>
-          <p:cNvCxnSpPr>
-            <a:stCxn xmlns:a="http://schemas.openxmlformats.org/drawingml/2006/main" id="8" idx="2"/>
-            <a:endCxn xmlns:a="http://schemas.openxmlformats.org/drawingml/2006/main" id="10" idx="0"/>
-          </p:cNvCxnSpPr>
-          <p:nvPr/>
-        </p:nvCxnSpPr>
-        <p:spPr>
-          <a:xfrm xmlns:a="http://schemas.openxmlformats.org/drawingml/2006/main">
-            <a:off x="2819400" y="2895600"/>
-            <a:ext cx="0" cy="114300"/>
-          </a:xfrm>
-          <a:prstGeom xmlns:a="http://schemas.openxmlformats.org/drawingml/2006/main" prst="straightConnector1">
-            <a:avLst/>
-          </a:prstGeom>
-          <a:ln xmlns:a="http://schemas.openxmlformats.org/drawingml/2006/main" w="23813">
-            <a:solidFill>
-              <a:srgbClr val="A66A00"/>
-            </a:solidFill>
-            <a:prstDash val="solid"/>
-            <a:tailEnd type="triangle" w="sm" len="sm"/>
-          </a:ln>
-        </p:spPr>
-      </p:cxnSp>
-      <p:cxnSp>
-        <p:nvCxnSpPr>
-          <p:cNvPr id="48" name=""/>
-          <p:cNvCxnSpPr>
-            <a:stCxn xmlns:a="http://schemas.openxmlformats.org/drawingml/2006/main" id="10" idx="1"/>
-            <a:endCxn xmlns:a="http://schemas.openxmlformats.org/drawingml/2006/main" id="7" idx="2"/>
-          </p:cNvCxnSpPr>
-          <p:nvPr/>
-        </p:nvCxnSpPr>
-        <p:spPr>
-          <a:xfrm xmlns:a="http://schemas.openxmlformats.org/drawingml/2006/main" flipH="1" flipV="1">
-            <a:off x="952500" y="2895600"/>
-            <a:ext cx="1028700" cy="457200"/>
-          </a:xfrm>
-          <a:prstGeom xmlns:a="http://schemas.openxmlformats.org/drawingml/2006/main" prst="bentConnector2">
-            <a:avLst/>
-          </a:prstGeom>
-          <a:ln xmlns:a="http://schemas.openxmlformats.org/drawingml/2006/main" w="23813">
-            <a:solidFill>
-              <a:srgbClr val="A66A00"/>
-            </a:solidFill>
-            <a:prstDash val="solid"/>
-            <a:tailEnd type="triangle" w="sm" len="sm"/>
-          </a:ln>
-        </p:spPr>
-      </p:cxnSp>
-      <p:sp>
-        <p:nvSpPr>
-          <p:cNvPr id="21" name="">
-            <a:extLst xmlns:a="http://schemas.openxmlformats.org/drawingml/2006/main">
-              <a:ext uri="{FF2B5EF4-FFF2-40B4-BE49-F238E27FC236}">
-                <a16:creationId xmlns:a16="http://schemas.microsoft.com/office/drawing/2014/main" id="{EA07503D-9A4F-44C1-8ACD-97032BFC90AE}"/>
-              </a:ext>
-            </a:extLst>
-          </p:cNvPr>
-          <p:cNvSpPr>
-            <a:spLocks xmlns:a="http://schemas.openxmlformats.org/drawingml/2006/main" noGrp="1"/>
-          </p:cNvSpPr>
-          <p:nvPr/>
-        </p:nvSpPr>
-        <p:spPr>
-          <a:xfrm xmlns:a="http://schemas.openxmlformats.org/drawingml/2006/main">
-            <a:off x="4000500" y="3143250"/>
-            <a:ext cx="3905250" cy="209550"/>
-          </a:xfrm>
-          <a:prstGeom xmlns:a="http://schemas.openxmlformats.org/drawingml/2006/main" prst="rect">
-            <a:avLst/>
-          </a:prstGeom>
-          <a:noFill xmlns:a="http://schemas.openxmlformats.org/drawingml/2006/main"/>
-          <a:ln xmlns:a="http://schemas.openxmlformats.org/drawingml/2006/main" w="0">
-            <a:noFill/>
-            <a:prstDash val="solid"/>
-          </a:ln>
-        </p:spPr>
-        <p:txBody>
-          <a:bodyPr xmlns:a="http://schemas.openxmlformats.org/drawingml/2006/main" wrap="square" lIns="0" tIns="0" rIns="0" bIns="0" anchor="t">
-            <a:normAutofit fontScale="100000"/>
-          </a:bodyPr>
-          <a:lstStyle xmlns:a="http://schemas.openxmlformats.org/drawingml/2006/main"/>
-          <a:p xmlns:a="http://schemas.openxmlformats.org/drawingml/2006/main">
-            <a:pPr algn="ctr">
-              <a:defRPr sz="975" b="1">
-                <a:solidFill>
-                  <a:srgbClr val="A66A00"/>
-                </a:solidFill>
-                <a:latin typeface="Noto Sans JP Thin"/>
-                <a:ea typeface="Noto Sans JP Thin"/>
-                <a:cs typeface="Noto Sans JP Thin"/>
-              </a:defRPr>
-            </a:pPr>
-            <a:r>
-              <a:rPr sz="975" b="1">
-                <a:solidFill>
-                  <a:srgbClr val="A66A00"/>
-                </a:solidFill>
-                <a:latin typeface="Noto Sans JP Thin"/>
-                <a:ea typeface="Noto Sans JP Thin"/>
-                <a:cs typeface="Noto Sans JP Thin"/>
-              </a:rPr>
-              <a:t>API障害・不正call時も、不足／未定／矛盾は安全停止</a:t>
-            </a:r>
-          </a:p>
-        </p:txBody>
-      </p:sp>
-      <p:sp>
-        <p:nvSpPr>
-          <p:cNvPr id="22" name="">
-            <a:extLst xmlns:a="http://schemas.openxmlformats.org/drawingml/2006/main">
-              <a:ext uri="{FF2B5EF4-FFF2-40B4-BE49-F238E27FC236}">
-                <a16:creationId xmlns:a16="http://schemas.microsoft.com/office/drawing/2014/main" id="{C2D15D36-E745-4111-AE23-B99533401B66}"/>
-              </a:ext>
-            </a:extLst>
-          </p:cNvPr>
-          <p:cNvSpPr>
-            <a:spLocks xmlns:a="http://schemas.openxmlformats.org/drawingml/2006/main" noGrp="1"/>
-          </p:cNvSpPr>
-          <p:nvPr/>
-        </p:nvSpPr>
-        <p:spPr>
-          <a:xfrm xmlns:a="http://schemas.openxmlformats.org/drawingml/2006/main">
-            <a:off x="3848100" y="3467100"/>
-            <a:ext cx="4343400" cy="247650"/>
-          </a:xfrm>
-          <a:prstGeom xmlns:a="http://schemas.openxmlformats.org/drawingml/2006/main" prst="roundRect">
-            <a:avLst>
-              <a:gd name="adj" fmla="val 50000"/>
-            </a:avLst>
-          </a:prstGeom>
-          <a:solidFill xmlns:a="http://schemas.openxmlformats.org/drawingml/2006/main">
-            <a:srgbClr val="EDF4F9"/>
-          </a:solidFill>
-          <a:ln xmlns:a="http://schemas.openxmlformats.org/drawingml/2006/main" w="0">
-            <a:noFill/>
-            <a:prstDash val="solid"/>
-          </a:ln>
-        </p:spPr>
-        <p:txBody>
-          <a:bodyPr xmlns:a="http://schemas.openxmlformats.org/drawingml/2006/main" wrap="square" lIns="95250" tIns="19050" rIns="95250" bIns="19050" anchor="ctr">
-            <a:normAutofit fontScale="99895"/>
-          </a:bodyPr>
-          <a:lstStyle xmlns:a="http://schemas.openxmlformats.org/drawingml/2006/main"/>
-          <a:p xmlns:a="http://schemas.openxmlformats.org/drawingml/2006/main">
-            <a:pPr algn="ctr">
-              <a:defRPr sz="900" b="1">
-                <a:solidFill>
-                  <a:srgbClr val="17324D"/>
-                </a:solidFill>
-                <a:latin typeface="Noto Sans JP Thin"/>
-                <a:ea typeface="Noto Sans JP Thin"/>
-                <a:cs typeface="Noto Sans JP Thin"/>
-              </a:defRPr>
-            </a:pPr>
-            <a:r>
-              <a:rPr sz="900" b="1">
-                <a:solidFill>
-                  <a:srgbClr val="17324D"/>
-                </a:solidFill>
-                <a:latin typeface="Noto Sans JP Thin"/>
-                <a:ea typeface="Noto Sans JP Thin"/>
-                <a:cs typeface="Noto Sans JP Thin"/>
-              </a:rPr>
-              <a:t>Cloud Run  /  訪問者別Cookieセッション  /  公開M1はメモリ状態</a:t>
-            </a:r>
-          </a:p>
-        </p:txBody>
-      </p:sp>
-      <p:sp>
-        <p:nvSpPr>
-          <p:cNvPr id="23" name="">
-            <a:extLst xmlns:a="http://schemas.openxmlformats.org/drawingml/2006/main">
-              <a:ext uri="{FF2B5EF4-FFF2-40B4-BE49-F238E27FC236}">
-                <a16:creationId xmlns:a16="http://schemas.microsoft.com/office/drawing/2014/main" id="{B5F8A603-4268-4FCB-94A3-F73B2EF9260D}"/>
-              </a:ext>
-            </a:extLst>
-          </p:cNvPr>
-          <p:cNvSpPr>
-            <a:spLocks xmlns:a="http://schemas.openxmlformats.org/drawingml/2006/main" noGrp="1"/>
-          </p:cNvSpPr>
-          <p:nvPr/>
-        </p:nvSpPr>
-        <p:spPr>
-          <a:xfrm xmlns:a="http://schemas.openxmlformats.org/drawingml/2006/main">
-            <a:off x="1485900" y="4362450"/>
-            <a:ext cx="1257300" cy="628650"/>
-          </a:xfrm>
-          <a:prstGeom xmlns:a="http://schemas.openxmlformats.org/drawingml/2006/main" prst="roundRect">
-            <a:avLst>
-              <a:gd name="adj" fmla="val 24242"/>
-            </a:avLst>
-          </a:prstGeom>
-          <a:solidFill xmlns:a="http://schemas.openxmlformats.org/drawingml/2006/main">
-            <a:srgbClr val="FFFFFF"/>
-          </a:solidFill>
-          <a:ln xmlns:a="http://schemas.openxmlformats.org/drawingml/2006/main" w="14288">
-            <a:solidFill>
-              <a:srgbClr val="17324D"/>
-            </a:solidFill>
-            <a:prstDash val="solid"/>
-          </a:ln>
-        </p:spPr>
-        <p:txBody>
-          <a:bodyPr xmlns:a="http://schemas.openxmlformats.org/drawingml/2006/main" wrap="square" lIns="47625" tIns="47625" rIns="47625" bIns="47625" anchor="ctr">
-            <a:normAutofit fontScale="100000"/>
-          </a:bodyPr>
-          <a:lstStyle xmlns:a="http://schemas.openxmlformats.org/drawingml/2006/main"/>
-          <a:p xmlns:a="http://schemas.openxmlformats.org/drawingml/2006/main">
-            <a:pPr algn="ctr">
-              <a:defRPr sz="1125" b="1">
-                <a:solidFill>
-                  <a:srgbClr val="17324D"/>
-                </a:solidFill>
-                <a:latin typeface="Noto Sans JP Thin"/>
-                <a:ea typeface="Noto Sans JP Thin"/>
-                <a:cs typeface="Noto Sans JP Thin"/>
-              </a:defRPr>
-            </a:pPr>
-            <a:r>
-              <a:rPr sz="1125" b="1">
-                <a:solidFill>
-                  <a:srgbClr val="17324D"/>
-                </a:solidFill>
-                <a:latin typeface="Noto Sans JP Thin"/>
-                <a:ea typeface="Noto Sans JP Thin"/>
-                <a:cs typeface="Noto Sans JP Thin"/>
-              </a:rPr>
-              <a:t>GitHub</a:t>
-            </a:r>
-          </a:p>
-          <a:p xmlns:a="http://schemas.openxmlformats.org/drawingml/2006/main">
-            <a:pPr algn="ctr">
-              <a:defRPr sz="1125" b="1">
-                <a:solidFill>
-                  <a:srgbClr val="17324D"/>
-                </a:solidFill>
-                <a:latin typeface="Noto Sans JP Thin"/>
-                <a:ea typeface="Noto Sans JP Thin"/>
-                <a:cs typeface="Noto Sans JP Thin"/>
-              </a:defRPr>
-            </a:pPr>
-            <a:r>
-              <a:rPr sz="1125" b="1">
-                <a:solidFill>
-                  <a:srgbClr val="17324D"/>
-                </a:solidFill>
-                <a:latin typeface="Noto Sans JP Thin"/>
-                <a:ea typeface="Noto Sans JP Thin"/>
-                <a:cs typeface="Noto Sans JP Thin"/>
-              </a:rPr>
-              <a:t>専門知＋rules</a:t>
-            </a:r>
-          </a:p>
-        </p:txBody>
-      </p:sp>
-      <p:sp>
-        <p:nvSpPr>
-          <p:cNvPr id="24" name="">
-            <a:extLst xmlns:a="http://schemas.openxmlformats.org/drawingml/2006/main">
-              <a:ext uri="{FF2B5EF4-FFF2-40B4-BE49-F238E27FC236}">
-                <a16:creationId xmlns:a16="http://schemas.microsoft.com/office/drawing/2014/main" id="{B41EDE2C-F312-4026-803E-0C3EDDDF402B}"/>
-              </a:ext>
-            </a:extLst>
-          </p:cNvPr>
-          <p:cNvSpPr>
-            <a:spLocks xmlns:a="http://schemas.openxmlformats.org/drawingml/2006/main" noGrp="1"/>
-          </p:cNvSpPr>
-          <p:nvPr/>
-        </p:nvSpPr>
-        <p:spPr>
-          <a:xfrm xmlns:a="http://schemas.openxmlformats.org/drawingml/2006/main">
-            <a:off x="3295650" y="4324350"/>
-            <a:ext cx="2667000" cy="685800"/>
-          </a:xfrm>
-          <a:prstGeom xmlns:a="http://schemas.openxmlformats.org/drawingml/2006/main" prst="roundRect">
-            <a:avLst>
-              <a:gd name="adj" fmla="val 22222"/>
-            </a:avLst>
-          </a:prstGeom>
-          <a:solidFill xmlns:a="http://schemas.openxmlformats.org/drawingml/2006/main">
-            <a:srgbClr val="E5F7EE"/>
           </a:solidFill>
           <a:ln xmlns:a="http://schemas.openxmlformats.org/drawingml/2006/main" w="14288">
             <a:solidFill>
@@ -5590,6 +6141,12 @@
             <a:prstDash val="solid"/>
           </a:ln>
         </p:spPr>
+        <p:style>
+          <a:lnRef xmlns:a="http://schemas.openxmlformats.org/drawingml/2006/main" idx="0"/>
+          <a:fillRef xmlns:a="http://schemas.openxmlformats.org/drawingml/2006/main" idx="0"/>
+          <a:effectRef xmlns:a="http://schemas.openxmlformats.org/drawingml/2006/main" idx="4"/>
+          <a:fontRef xmlns:a="http://schemas.openxmlformats.org/drawingml/2006/main" idx="major"/>
+        </p:style>
         <p:txBody>
           <a:bodyPr xmlns:a="http://schemas.openxmlformats.org/drawingml/2006/main" wrap="square" lIns="66675" tIns="47625" rIns="66675" bIns="47625" anchor="ctr">
             <a:normAutofit fontScale="100000"/>
@@ -5615,7 +6172,7 @@
                 <a:ea typeface="Noto Sans JP Thin"/>
                 <a:cs typeface="Noto Sans JP Thin"/>
               </a:rPr>
-              <a:t>GitHub Actions</a:t>
+              <a:t>合格した版だけ</a:t>
             </a:r>
           </a:p>
           <a:p xmlns:a="http://schemas.openxmlformats.org/drawingml/2006/main">
@@ -5638,168 +6195,29 @@
                 <a:ea typeface="Noto Sans JP Thin"/>
                 <a:cs typeface="Noto Sans JP Thin"/>
               </a:rPr>
-              <a:t>secret → pytest 72 → Docker → health smoke</a:t>
-            </a:r>
-          </a:p>
-        </p:txBody>
-      </p:sp>
-      <p:sp>
-        <p:nvSpPr>
-          <p:cNvPr id="25" name="">
-            <a:extLst xmlns:a="http://schemas.openxmlformats.org/drawingml/2006/main">
-              <a:ext uri="{FF2B5EF4-FFF2-40B4-BE49-F238E27FC236}">
-                <a16:creationId xmlns:a16="http://schemas.microsoft.com/office/drawing/2014/main" id="{5B68C599-62B3-4B17-8437-DB81D0E23034}"/>
-              </a:ext>
-            </a:extLst>
-          </p:cNvPr>
-          <p:cNvSpPr>
-            <a:spLocks xmlns:a="http://schemas.openxmlformats.org/drawingml/2006/main" noGrp="1"/>
-          </p:cNvSpPr>
-          <p:nvPr/>
-        </p:nvSpPr>
-        <p:spPr>
-          <a:xfrm xmlns:a="http://schemas.openxmlformats.org/drawingml/2006/main">
-            <a:off x="6515100" y="4324350"/>
-            <a:ext cx="2000250" cy="685800"/>
-          </a:xfrm>
-          <a:prstGeom xmlns:a="http://schemas.openxmlformats.org/drawingml/2006/main" prst="roundRect">
-            <a:avLst>
-              <a:gd name="adj" fmla="val 22222"/>
-            </a:avLst>
-          </a:prstGeom>
-          <a:solidFill xmlns:a="http://schemas.openxmlformats.org/drawingml/2006/main">
-            <a:srgbClr val="FFFFFF"/>
-          </a:solidFill>
-          <a:ln xmlns:a="http://schemas.openxmlformats.org/drawingml/2006/main" w="14288">
-            <a:solidFill>
-              <a:srgbClr val="15845C"/>
-            </a:solidFill>
-            <a:prstDash val="solid"/>
-          </a:ln>
-        </p:spPr>
-        <p:txBody>
-          <a:bodyPr xmlns:a="http://schemas.openxmlformats.org/drawingml/2006/main" wrap="square" lIns="66675" tIns="47625" rIns="66675" bIns="47625" anchor="ctr">
-            <a:normAutofit fontScale="100000"/>
-          </a:bodyPr>
-          <a:lstStyle xmlns:a="http://schemas.openxmlformats.org/drawingml/2006/main"/>
-          <a:p xmlns:a="http://schemas.openxmlformats.org/drawingml/2006/main">
-            <a:pPr algn="ctr">
-              <a:defRPr sz="1050" b="1">
-                <a:solidFill>
-                  <a:srgbClr val="15845C"/>
-                </a:solidFill>
-                <a:latin typeface="Noto Sans JP Thin"/>
-                <a:ea typeface="Noto Sans JP Thin"/>
-                <a:cs typeface="Noto Sans JP Thin"/>
-              </a:defRPr>
-            </a:pPr>
-            <a:r>
-              <a:rPr sz="1050" b="1">
-                <a:solidFill>
-                  <a:srgbClr val="15845C"/>
-                </a:solidFill>
-                <a:latin typeface="Noto Sans JP Thin"/>
-                <a:ea typeface="Noto Sans JP Thin"/>
-                <a:cs typeface="Noto Sans JP Thin"/>
-              </a:rPr>
-              <a:t>CI合格後に手動deploy</a:t>
-            </a:r>
-          </a:p>
-          <a:p xmlns:a="http://schemas.openxmlformats.org/drawingml/2006/main">
-            <a:pPr algn="ctr">
-              <a:defRPr sz="1050" b="1">
-                <a:solidFill>
-                  <a:srgbClr val="15845C"/>
-                </a:solidFill>
-                <a:latin typeface="Noto Sans JP Thin"/>
-                <a:ea typeface="Noto Sans JP Thin"/>
-                <a:cs typeface="Noto Sans JP Thin"/>
-              </a:defRPr>
-            </a:pPr>
-            <a:r>
-              <a:rPr sz="1050" b="1">
-                <a:solidFill>
-                  <a:srgbClr val="15845C"/>
-                </a:solidFill>
-                <a:latin typeface="Noto Sans JP Thin"/>
-                <a:ea typeface="Noto Sans JP Thin"/>
-                <a:cs typeface="Noto Sans JP Thin"/>
-              </a:rPr>
-              <a:t>APP_VERSION = 公開main SHA</a:t>
-            </a:r>
-          </a:p>
-        </p:txBody>
-      </p:sp>
-      <p:cxnSp>
-        <p:nvCxnSpPr>
-          <p:cNvPr id="54" name=""/>
-          <p:cNvCxnSpPr>
-            <a:stCxn xmlns:a="http://schemas.openxmlformats.org/drawingml/2006/main" id="23" idx="3"/>
-            <a:endCxn xmlns:a="http://schemas.openxmlformats.org/drawingml/2006/main" id="24" idx="1"/>
-          </p:cNvCxnSpPr>
-          <p:nvPr/>
-        </p:nvCxnSpPr>
-        <p:spPr>
-          <a:xfrm xmlns:a="http://schemas.openxmlformats.org/drawingml/2006/main" flipV="1">
-            <a:off x="2743200" y="4667250"/>
-            <a:ext cx="552450" cy="9525"/>
-          </a:xfrm>
-          <a:prstGeom xmlns:a="http://schemas.openxmlformats.org/drawingml/2006/main" prst="straightConnector1">
-            <a:avLst/>
-          </a:prstGeom>
-          <a:ln xmlns:a="http://schemas.openxmlformats.org/drawingml/2006/main" w="23813">
-            <a:solidFill>
-              <a:srgbClr val="15845C"/>
-            </a:solidFill>
-            <a:prstDash val="solid"/>
-            <a:tailEnd type="triangle" w="sm" len="sm"/>
-          </a:ln>
-        </p:spPr>
-      </p:cxnSp>
-      <p:cxnSp>
-        <p:nvCxnSpPr>
-          <p:cNvPr id="55" name=""/>
-          <p:cNvCxnSpPr>
-            <a:stCxn xmlns:a="http://schemas.openxmlformats.org/drawingml/2006/main" id="24" idx="3"/>
-            <a:endCxn xmlns:a="http://schemas.openxmlformats.org/drawingml/2006/main" id="25" idx="1"/>
-          </p:cNvCxnSpPr>
-          <p:nvPr/>
-        </p:nvCxnSpPr>
-        <p:spPr>
-          <a:xfrm xmlns:a="http://schemas.openxmlformats.org/drawingml/2006/main">
-            <a:off x="5962650" y="4667250"/>
-            <a:ext cx="552450" cy="0"/>
-          </a:xfrm>
-          <a:prstGeom xmlns:a="http://schemas.openxmlformats.org/drawingml/2006/main" prst="straightConnector1">
-            <a:avLst/>
-          </a:prstGeom>
-          <a:ln xmlns:a="http://schemas.openxmlformats.org/drawingml/2006/main" w="23813">
-            <a:solidFill>
-              <a:srgbClr val="15845C"/>
-            </a:solidFill>
-            <a:prstDash val="solid"/>
-            <a:tailEnd type="triangle" w="sm" len="sm"/>
-          </a:ln>
-        </p:spPr>
-      </p:cxnSp>
-      <p:sp>
-        <p:nvSpPr>
-          <p:cNvPr id="28" name="">
-            <a:extLst xmlns:a="http://schemas.openxmlformats.org/drawingml/2006/main">
-              <a:ext uri="{FF2B5EF4-FFF2-40B4-BE49-F238E27FC236}">
-                <a16:creationId xmlns:a16="http://schemas.microsoft.com/office/drawing/2014/main" id="{1C6DD7E8-644A-43B3-A0CD-9AE1E22CA7EA}"/>
-              </a:ext>
-            </a:extLst>
-          </p:cNvPr>
-          <p:cNvSpPr>
-            <a:spLocks xmlns:a="http://schemas.openxmlformats.org/drawingml/2006/main" noGrp="1"/>
-          </p:cNvSpPr>
-          <p:nvPr/>
-        </p:nvSpPr>
-        <p:spPr>
-          <a:xfrm xmlns:a="http://schemas.openxmlformats.org/drawingml/2006/main">
-            <a:off x="1524000" y="5010150"/>
-            <a:ext cx="6934200" cy="171450"/>
+              <a:t>手動でCloud Runへ公開</a:t>
+            </a:r>
+          </a:p>
+        </p:txBody>
+      </p:sp>
+      <p:sp>
+        <p:nvSpPr>
+          <p:cNvPr id="36" name="">
+            <a:extLst xmlns:a="http://schemas.openxmlformats.org/drawingml/2006/main">
+              <a:ext uri="{FF2B5EF4-FFF2-40B4-BE49-F238E27FC236}">
+                <a16:creationId xmlns:a16="http://schemas.microsoft.com/office/drawing/2014/main" id="{BE34EE9B-CDD0-4F67-A43E-2276FF924D8E}"/>
+              </a:ext>
+            </a:extLst>
+          </p:cNvPr>
+          <p:cNvSpPr>
+            <a:spLocks xmlns:a="http://schemas.openxmlformats.org/drawingml/2006/main" noGrp="1"/>
+          </p:cNvSpPr>
+          <p:nvPr/>
+        </p:nvSpPr>
+        <p:spPr>
+          <a:xfrm xmlns:a="http://schemas.openxmlformats.org/drawingml/2006/main">
+            <a:off x="1676400" y="5010150"/>
+            <a:ext cx="7200900" cy="152400"/>
           </a:xfrm>
           <a:prstGeom xmlns:a="http://schemas.openxmlformats.org/drawingml/2006/main" prst="rect">
             <a:avLst/>
@@ -5817,7 +6235,7 @@
           <a:lstStyle xmlns:a="http://schemas.openxmlformats.org/drawingml/2006/main"/>
           <a:p xmlns:a="http://schemas.openxmlformats.org/drawingml/2006/main">
             <a:pPr algn="ctr">
-              <a:defRPr sz="900" b="1">
+              <a:defRPr sz="825" b="1">
                 <a:solidFill>
                   <a:srgbClr val="15845C"/>
                 </a:solidFill>
@@ -5827,7 +6245,7 @@
               </a:defRPr>
             </a:pPr>
             <a:r>
-              <a:rPr sz="900" b="1">
+              <a:rPr sz="825" b="1">
                 <a:solidFill>
                   <a:srgbClr val="15845C"/>
                 </a:solidFill>
@@ -5835,7 +6253,7 @@
                 <a:ea typeface="Noto Sans JP Thin"/>
                 <a:cs typeface="Noto Sans JP Thin"/>
               </a:rPr>
-              <a:t>production_evidence.py  ｜  SHA一致・実Gemini・9分岐・問い返し再開・Word E2E</a:t>
+              <a:t>本番確認：公開SHA一致・実Gemini接続・9分岐・安全停止／再開・Word出力</a:t>
             </a:r>
           </a:p>
         </p:txBody>
@@ -5843,7 +6261,7 @@
     </p:spTree>
     <p:extLst>
       <p:ext uri="{BB962C8B-B14F-4D97-AF65-F5344CB8AC3E}">
-        <p14:creationId xmlns:p14="http://schemas.microsoft.com/office/powerpoint/2010/main" val="416512904"/>
+        <p14:creationId xmlns:p14="http://schemas.microsoft.com/office/powerpoint/2010/main" val="1648740366"/>
       </p:ext>
     </p:extLst>
   </p:cSld>

</xml_diff>